<commit_message>
Add live demo screenshots to progress presentation
</commit_message>
<xml_diff>
--- a/presentation/Smart_Parking_MQTT_Presentation_EN.pptx
+++ b/presentation/Smart_Parking_MQTT_Presentation_EN.pptx
@@ -11,8 +11,6 @@
     <p:sldId id="259" r:id="rId10"/>
     <p:sldId id="260" r:id="rId11"/>
     <p:sldId id="261" r:id="rId12"/>
-    <p:sldId id="262" r:id="rId13"/>
-    <p:sldId id="263" r:id="rId14"/>
   </p:sldIdLst>
   <p:sldSz cx="12191695" cy="6858000" type="screen4x3"/>
   <p:notesSz cx="6858000" cy="9144000"/>
@@ -3091,7 +3089,7 @@
     <p:bg>
       <p:bgPr>
         <a:solidFill>
-          <a:srgbClr val="F7F9FC"/>
+          <a:srgbClr val="F6F8FC"/>
         </a:solidFill>
         <a:effectLst/>
       </p:bgPr>
@@ -3112,13 +3110,13 @@
         <p:spPr>
           <a:xfrm>
             <a:off x="0" y="0"/>
-            <a:ext cx="12191695" cy="411480"/>
+            <a:ext cx="12191695" cy="384048"/>
           </a:xfrm>
           <a:prstGeom prst="rect">
             <a:avLst/>
           </a:prstGeom>
           <a:solidFill>
-            <a:srgbClr val="192C4C"/>
+            <a:srgbClr val="182C4C"/>
           </a:solidFill>
           <a:ln>
             <a:noFill/>
@@ -3154,8 +3152,8 @@
         </p:nvSpPr>
         <p:spPr>
           <a:xfrm>
-            <a:off x="731520" y="1005840"/>
-            <a:ext cx="10698480" cy="4754880"/>
+            <a:off x="749808" y="960120"/>
+            <a:ext cx="10698480" cy="4983480"/>
           </a:xfrm>
           <a:prstGeom prst="roundRect">
             <a:avLst/>
@@ -3199,8 +3197,8 @@
         </p:nvSpPr>
         <p:spPr>
           <a:xfrm>
-            <a:off x="1051560" y="1508760"/>
-            <a:ext cx="9601200" cy="2560320"/>
+            <a:off x="1078992" y="1417320"/>
+            <a:ext cx="9784080" cy="2743200"/>
           </a:xfrm>
           <a:prstGeom prst="rect">
             <a:avLst/>
@@ -3208,7 +3206,7 @@
           <a:noFill/>
         </p:spPr>
         <p:txBody>
-          <a:bodyPr wrap="square">
+          <a:bodyPr wrap="none">
             <a:spAutoFit/>
           </a:bodyPr>
           <a:lstStyle/>
@@ -3216,33 +3214,33 @@
             <a:r>
               <a:rPr sz="3000" b="1">
                 <a:solidFill>
-                  <a:srgbClr val="192C4C"/>
+                  <a:srgbClr val="182C4C"/>
                 </a:solidFill>
                 <a:latin typeface="Aptos"/>
               </a:rPr>
-              <a:t>Smart Parking Prototype Based on MQTT</a:t>
+              <a:t>Smart Parking MQTT Prototype</a:t>
             </a:r>
           </a:p>
           <a:p>
             <a:r>
               <a:rPr sz="1800">
                 <a:solidFill>
-                  <a:srgbClr val="235BA6"/>
+                  <a:srgbClr val="225CA5"/>
                 </a:solidFill>
                 <a:latin typeface="Aptos"/>
               </a:rPr>
-              <a:t>Week 4-5 Coursework Presentation</a:t>
-            </a:r>
-          </a:p>
-          <a:p>
-            <a:r>
-              <a:rPr sz="1900">
-                <a:solidFill>
-                  <a:srgbClr val="2E3846"/>
+              <a:t>Current Progress Presentation</a:t>
+            </a:r>
+          </a:p>
+          <a:p>
+            <a:r>
+              <a:rPr sz="1800">
+                <a:solidFill>
+                  <a:srgbClr val="3D4858"/>
                 </a:solidFill>
                 <a:latin typeface="Aptos"/>
               </a:rPr>
-              <a:t>This project presents a simple Internet of Things prototype for a smart parking lot. The system uses MQTT to connect parking sensors, a display service, a statistics service, and an entry gate controller in one shared message-driven workflow.</a:t>
+              <a:t>This version of the presentation focuses on the current implementation progress. Instead of repeating the project background, it shows the modules that are already working, the live demo output captured from the current codebase, and the recent GitHub development record.</a:t>
             </a:r>
           </a:p>
         </p:txBody>
@@ -3255,14 +3253,14 @@
         </p:nvSpPr>
         <p:spPr>
           <a:xfrm>
-            <a:off x="1051560" y="4526280"/>
-            <a:ext cx="2331720" cy="548640"/>
+            <a:off x="1078992" y="4572000"/>
+            <a:ext cx="2788920" cy="502920"/>
           </a:xfrm>
           <a:prstGeom prst="roundRect">
             <a:avLst/>
           </a:prstGeom>
           <a:solidFill>
-            <a:srgbClr val="2A8F88"/>
+            <a:srgbClr val="25887F"/>
           </a:solidFill>
           <a:ln>
             <a:noFill/>
@@ -3286,7 +3284,7 @@
           <a:bodyPr rtlCol="0" anchor="ctr"/>
           <a:lstStyle/>
           <a:p>
-            <a:pPr algn="ctr">
+            <a:pPr>
               <a:defRPr sz="1600" b="1">
                 <a:solidFill>
                   <a:srgbClr val="FFFFFF"/>
@@ -3295,43 +3293,7 @@
               </a:defRPr>
             </a:pPr>
             <a:r>
-              <a:t>Python + MQTT</a:t>
-            </a:r>
-          </a:p>
-        </p:txBody>
-      </p:sp>
-      <p:sp>
-        <p:nvSpPr>
-          <p:cNvPr id="6" name="TextBox 5"/>
-          <p:cNvSpPr txBox="1"/>
-          <p:nvPr/>
-        </p:nvSpPr>
-        <p:spPr>
-          <a:xfrm>
-            <a:off x="1051560" y="5257800"/>
-            <a:ext cx="9326880" cy="457200"/>
-          </a:xfrm>
-          <a:prstGeom prst="rect">
-            <a:avLst/>
-          </a:prstGeom>
-          <a:noFill/>
-        </p:spPr>
-        <p:txBody>
-          <a:bodyPr wrap="none">
-            <a:spAutoFit/>
-          </a:bodyPr>
-          <a:lstStyle/>
-          <a:p>
-            <a:pPr>
-              <a:defRPr sz="1500">
-                <a:solidFill>
-                  <a:srgbClr val="2E3846"/>
-                </a:solidFill>
-                <a:latin typeface="Aptos"/>
-              </a:defRPr>
-            </a:pPr>
-            <a:r>
-              <a:t>The aim of this prototype is not to build a full commercial platform, but to demonstrate a clear and working MQTT communication architecture.</a:t>
+              <a:t>Live demo + GitHub progress</a:t>
             </a:r>
           </a:p>
         </p:txBody>
@@ -3350,7 +3312,7 @@
     <p:bg>
       <p:bgPr>
         <a:solidFill>
-          <a:srgbClr val="F7F9FC"/>
+          <a:srgbClr val="F6F8FC"/>
         </a:solidFill>
         <a:effectLst/>
       </p:bgPr>
@@ -3371,13 +3333,13 @@
         <p:spPr>
           <a:xfrm>
             <a:off x="0" y="0"/>
-            <a:ext cx="12191695" cy="411480"/>
+            <a:ext cx="12191695" cy="384048"/>
           </a:xfrm>
           <a:prstGeom prst="rect">
             <a:avLst/>
           </a:prstGeom>
           <a:solidFill>
-            <a:srgbClr val="192C4C"/>
+            <a:srgbClr val="182C4C"/>
           </a:solidFill>
           <a:ln>
             <a:noFill/>
@@ -3413,7 +3375,7 @@
         </p:nvSpPr>
         <p:spPr>
           <a:xfrm>
-            <a:off x="640080" y="658368"/>
+            <a:off x="640080" y="640080"/>
             <a:ext cx="10972800" cy="822960"/>
           </a:xfrm>
           <a:prstGeom prst="rect">
@@ -3422,30 +3384,30 @@
           <a:noFill/>
         </p:spPr>
         <p:txBody>
-          <a:bodyPr wrap="square">
+          <a:bodyPr wrap="none">
             <a:spAutoFit/>
           </a:bodyPr>
           <a:lstStyle/>
           <a:p>
             <a:r>
-              <a:rPr sz="2600" b="1">
-                <a:solidFill>
-                  <a:srgbClr val="192C4C"/>
+              <a:rPr sz="2500" b="1">
+                <a:solidFill>
+                  <a:srgbClr val="182C4C"/>
                 </a:solidFill>
                 <a:latin typeface="Aptos"/>
               </a:rPr>
-              <a:t>1. Background and Problem Statement</a:t>
+              <a:t>1. Current Implementation Progress</a:t>
             </a:r>
           </a:p>
           <a:p>
             <a:r>
               <a:rPr sz="1300">
                 <a:solidFill>
-                  <a:srgbClr val="2E3846"/>
+                  <a:srgbClr val="3D4858"/>
                 </a:solidFill>
                 <a:latin typeface="Aptos"/>
               </a:rPr>
-              <a:t>A parking lot needs fast status updates and better coordination between physical devices.</a:t>
+              <a:t>The core MQTT workflow is already running end to end.</a:t>
             </a:r>
           </a:p>
         </p:txBody>
@@ -3458,8 +3420,8 @@
         </p:nvSpPr>
         <p:spPr>
           <a:xfrm>
-            <a:off x="777240" y="1600200"/>
-            <a:ext cx="5212080" cy="4389120"/>
+            <a:off x="777240" y="1645920"/>
+            <a:ext cx="3657600" cy="4480560"/>
           </a:xfrm>
           <a:prstGeom prst="roundRect">
             <a:avLst/>
@@ -3503,8 +3465,8 @@
         </p:nvSpPr>
         <p:spPr>
           <a:xfrm>
-            <a:off x="941832" y="1709928"/>
-            <a:ext cx="4882896" cy="4169663"/>
+            <a:off x="941832" y="1755648"/>
+            <a:ext cx="3328416" cy="4261104"/>
           </a:xfrm>
           <a:prstGeom prst="rect">
             <a:avLst/>
@@ -3512,21 +3474,21 @@
           <a:noFill/>
         </p:spPr>
         <p:txBody>
-          <a:bodyPr wrap="square">
+          <a:bodyPr wrap="none">
             <a:spAutoFit/>
           </a:bodyPr>
           <a:lstStyle/>
           <a:p>
             <a:pPr>
-              <a:defRPr sz="1900" b="1">
-                <a:solidFill>
-                  <a:srgbClr val="192C4C"/>
+              <a:defRPr sz="1800" b="1">
+                <a:solidFill>
+                  <a:srgbClr val="182C4C"/>
                 </a:solidFill>
                 <a:latin typeface="Aptos"/>
               </a:defRPr>
             </a:pPr>
             <a:r>
-              <a:t>Why this topic matters</a:t>
+              <a:t>Completed modules</a:t>
             </a:r>
           </a:p>
           <a:p>
@@ -3534,15 +3496,15 @@
               <a:spcAft>
                 <a:spcPts val="400"/>
               </a:spcAft>
-              <a:defRPr sz="1500">
-                <a:solidFill>
-                  <a:srgbClr val="2E3846"/>
+              <a:defRPr sz="1400">
+                <a:solidFill>
+                  <a:srgbClr val="3D4858"/>
                 </a:solidFill>
                 <a:latin typeface="Aptos"/>
               </a:defRPr>
             </a:pPr>
             <a:r>
-              <a:t>Drivers often waste time searching for available spaces, especially when the parking lot is busy.</a:t>
+              <a:t>Parking sensor simulation is publishing slot updates to MQTT topics.</a:t>
             </a:r>
           </a:p>
           <a:p>
@@ -3550,15 +3512,15 @@
               <a:spcAft>
                 <a:spcPts val="400"/>
               </a:spcAft>
-              <a:defRPr sz="1500">
-                <a:solidFill>
-                  <a:srgbClr val="2E3846"/>
+              <a:defRPr sz="1400">
+                <a:solidFill>
+                  <a:srgbClr val="3D4858"/>
                 </a:solidFill>
                 <a:latin typeface="Aptos"/>
               </a:defRPr>
             </a:pPr>
             <a:r>
-              <a:t>Traditional parking management is slow because information is updated manually or displayed too late.</a:t>
+              <a:t>The display module is subscribing to all parking status topics and showing a live dashboard.</a:t>
             </a:r>
           </a:p>
           <a:p>
@@ -3566,15 +3528,15 @@
               <a:spcAft>
                 <a:spcPts val="400"/>
               </a:spcAft>
-              <a:defRPr sz="1500">
-                <a:solidFill>
-                  <a:srgbClr val="2E3846"/>
+              <a:defRPr sz="1400">
+                <a:solidFill>
+                  <a:srgbClr val="3D4858"/>
                 </a:solidFill>
                 <a:latin typeface="Aptos"/>
               </a:defRPr>
             </a:pPr>
             <a:r>
-              <a:t>A message-based system can provide real-time communication between devices and services.</a:t>
+              <a:t>The statistics service is counting free and occupied spaces and publishing summary messages.</a:t>
             </a:r>
           </a:p>
           <a:p>
@@ -3582,15 +3544,15 @@
               <a:spcAft>
                 <a:spcPts val="400"/>
               </a:spcAft>
-              <a:defRPr sz="1500">
-                <a:solidFill>
-                  <a:srgbClr val="2E3846"/>
+              <a:defRPr sz="1400">
+                <a:solidFill>
+                  <a:srgbClr val="3D4858"/>
                 </a:solidFill>
                 <a:latin typeface="Aptos"/>
               </a:defRPr>
             </a:pPr>
             <a:r>
-              <a:t>MQTT is suitable for this scenario because it is lightweight, simple, and widely used in IoT projects.</a:t>
+              <a:t>The gate controller is making a real-time entry decision based on current availability.</a:t>
             </a:r>
           </a:p>
         </p:txBody>
@@ -3603,8 +3565,8 @@
         </p:nvSpPr>
         <p:spPr>
           <a:xfrm>
-            <a:off x="6217920" y="1600200"/>
-            <a:ext cx="5212080" cy="4389120"/>
+            <a:off x="4526280" y="1645920"/>
+            <a:ext cx="3657600" cy="4480560"/>
           </a:xfrm>
           <a:prstGeom prst="roundRect">
             <a:avLst/>
@@ -3648,8 +3610,8 @@
         </p:nvSpPr>
         <p:spPr>
           <a:xfrm>
-            <a:off x="6382512" y="1709928"/>
-            <a:ext cx="4882896" cy="4169663"/>
+            <a:off x="4690872" y="1755648"/>
+            <a:ext cx="3328416" cy="4261104"/>
           </a:xfrm>
           <a:prstGeom prst="rect">
             <a:avLst/>
@@ -3657,21 +3619,21 @@
           <a:noFill/>
         </p:spPr>
         <p:txBody>
-          <a:bodyPr wrap="square">
+          <a:bodyPr wrap="none">
             <a:spAutoFit/>
           </a:bodyPr>
           <a:lstStyle/>
           <a:p>
             <a:pPr>
-              <a:defRPr sz="1900" b="1">
-                <a:solidFill>
-                  <a:srgbClr val="192C4C"/>
+              <a:defRPr sz="1800" b="1">
+                <a:solidFill>
+                  <a:srgbClr val="182C4C"/>
                 </a:solidFill>
                 <a:latin typeface="Aptos"/>
               </a:defRPr>
             </a:pPr>
             <a:r>
-              <a:t>What our prototype tries to solve</a:t>
+              <a:t>New work added in this round</a:t>
             </a:r>
           </a:p>
           <a:p>
@@ -3679,15 +3641,15 @@
               <a:spcAft>
                 <a:spcPts val="400"/>
               </a:spcAft>
-              <a:defRPr sz="1500">
-                <a:solidFill>
-                  <a:srgbClr val="2E3846"/>
+              <a:defRPr sz="1400">
+                <a:solidFill>
+                  <a:srgbClr val="3D4858"/>
                 </a:solidFill>
                 <a:latin typeface="Aptos"/>
               </a:defRPr>
             </a:pPr>
             <a:r>
-              <a:t>Detect whether parking spaces are free or occupied through simulated sensors.</a:t>
+              <a:t>A vehicle request publisher was added so the gate logic depends on live MQTT events.</a:t>
             </a:r>
           </a:p>
           <a:p>
@@ -3695,15 +3657,15 @@
               <a:spcAft>
                 <a:spcPts val="400"/>
               </a:spcAft>
-              <a:defRPr sz="1500">
-                <a:solidFill>
-                  <a:srgbClr val="2E3846"/>
+              <a:defRPr sz="1400">
+                <a:solidFill>
+                  <a:srgbClr val="3D4858"/>
                 </a:solidFill>
                 <a:latin typeface="Aptos"/>
               </a:defRPr>
             </a:pPr>
             <a:r>
-              <a:t>Publish those updates to a broker so that multiple services can receive the same data immediately.</a:t>
+              <a:t>The gate controller was changed from a fixed-timer demo to a message-driven controller.</a:t>
             </a:r>
           </a:p>
           <a:p>
@@ -3711,15 +3673,15 @@
               <a:spcAft>
                 <a:spcPts val="400"/>
               </a:spcAft>
-              <a:defRPr sz="1500">
-                <a:solidFill>
-                  <a:srgbClr val="2E3846"/>
+              <a:defRPr sz="1400">
+                <a:solidFill>
+                  <a:srgbClr val="3D4858"/>
                 </a:solidFill>
                 <a:latin typeface="Aptos"/>
               </a:defRPr>
             </a:pPr>
             <a:r>
-              <a:t>Display the latest parking information in a simple monitoring dashboard.</a:t>
+              <a:t>The README and the project structure were cleaned up so the prototype is easier to run.</a:t>
             </a:r>
           </a:p>
           <a:p>
@@ -3727,15 +3689,109 @@
               <a:spcAft>
                 <a:spcPts val="400"/>
               </a:spcAft>
-              <a:defRPr sz="1500">
-                <a:solidFill>
-                  <a:srgbClr val="2E3846"/>
+              <a:defRPr sz="1400">
+                <a:solidFill>
+                  <a:srgbClr val="3D4858"/>
                 </a:solidFill>
                 <a:latin typeface="Aptos"/>
               </a:defRPr>
             </a:pPr>
             <a:r>
-              <a:t>Use the number of free spaces to decide whether the entry gate should open for a new car.</a:t>
+              <a:t>An English presentation deck and progress screenshots were prepared for the demo.</a:t>
+            </a:r>
+          </a:p>
+        </p:txBody>
+      </p:sp>
+      <p:sp>
+        <p:nvSpPr>
+          <p:cNvPr id="8" name="Rounded Rectangle 7"/>
+          <p:cNvSpPr/>
+          <p:nvPr/>
+        </p:nvSpPr>
+        <p:spPr>
+          <a:xfrm>
+            <a:off x="8275320" y="1645920"/>
+            <a:ext cx="3154680" cy="4480560"/>
+          </a:xfrm>
+          <a:prstGeom prst="roundRect">
+            <a:avLst/>
+          </a:prstGeom>
+          <a:solidFill>
+            <a:srgbClr val="FFFFFF"/>
+          </a:solidFill>
+          <a:ln>
+            <a:solidFill>
+              <a:srgbClr val="E4ECF7"/>
+            </a:solidFill>
+          </a:ln>
+        </p:spPr>
+        <p:style>
+          <a:lnRef idx="1">
+            <a:schemeClr val="accent1"/>
+          </a:lnRef>
+          <a:fillRef idx="3">
+            <a:schemeClr val="accent1"/>
+          </a:fillRef>
+          <a:effectRef idx="2">
+            <a:schemeClr val="accent1"/>
+          </a:effectRef>
+          <a:fontRef idx="minor">
+            <a:schemeClr val="lt1"/>
+          </a:fontRef>
+        </p:style>
+        <p:txBody>
+          <a:bodyPr rtlCol="0" anchor="ctr"/>
+          <a:lstStyle/>
+          <a:p>
+            <a:pPr algn="ctr"/>
+          </a:p>
+        </p:txBody>
+      </p:sp>
+      <p:sp>
+        <p:nvSpPr>
+          <p:cNvPr id="9" name="TextBox 8"/>
+          <p:cNvSpPr txBox="1"/>
+          <p:nvPr/>
+        </p:nvSpPr>
+        <p:spPr>
+          <a:xfrm>
+            <a:off x="8439912" y="1755648"/>
+            <a:ext cx="2825496" cy="4261104"/>
+          </a:xfrm>
+          <a:prstGeom prst="rect">
+            <a:avLst/>
+          </a:prstGeom>
+          <a:noFill/>
+        </p:spPr>
+        <p:txBody>
+          <a:bodyPr wrap="none">
+            <a:spAutoFit/>
+          </a:bodyPr>
+          <a:lstStyle/>
+          <a:p>
+            <a:pPr>
+              <a:defRPr sz="1800" b="1">
+                <a:solidFill>
+                  <a:srgbClr val="182C4C"/>
+                </a:solidFill>
+                <a:latin typeface="Aptos"/>
+              </a:defRPr>
+            </a:pPr>
+            <a:r>
+              <a:t>What this means</a:t>
+            </a:r>
+          </a:p>
+          <a:p>
+            <a:pPr>
+              <a:defRPr sz="1400">
+                <a:solidFill>
+                  <a:srgbClr val="3D4858"/>
+                </a:solidFill>
+                <a:latin typeface="Aptos"/>
+              </a:defRPr>
+            </a:pPr>
+            <a:r>
+              <a:t>At this stage, the project is no longer only a code sketch. It already behaves like a small distributed system. Different modules publish and subscribe to the same broker, and the output now demonstrates state updates, summary aggregation, and gate decisions based on current data.</a:t>
             </a:r>
           </a:p>
         </p:txBody>
@@ -3754,7 +3810,7 @@
     <p:bg>
       <p:bgPr>
         <a:solidFill>
-          <a:srgbClr val="F7F9FC"/>
+          <a:srgbClr val="F6F8FC"/>
         </a:solidFill>
         <a:effectLst/>
       </p:bgPr>
@@ -3775,13 +3831,13 @@
         <p:spPr>
           <a:xfrm>
             <a:off x="0" y="0"/>
-            <a:ext cx="12191695" cy="411480"/>
+            <a:ext cx="12191695" cy="384048"/>
           </a:xfrm>
           <a:prstGeom prst="rect">
             <a:avLst/>
           </a:prstGeom>
           <a:solidFill>
-            <a:srgbClr val="192C4C"/>
+            <a:srgbClr val="182C4C"/>
           </a:solidFill>
           <a:ln>
             <a:noFill/>
@@ -3817,7 +3873,7 @@
         </p:nvSpPr>
         <p:spPr>
           <a:xfrm>
-            <a:off x="640080" y="658368"/>
+            <a:off x="640080" y="640080"/>
             <a:ext cx="10972800" cy="822960"/>
           </a:xfrm>
           <a:prstGeom prst="rect">
@@ -3826,53 +3882,79 @@
           <a:noFill/>
         </p:spPr>
         <p:txBody>
-          <a:bodyPr wrap="square">
+          <a:bodyPr wrap="none">
             <a:spAutoFit/>
           </a:bodyPr>
           <a:lstStyle/>
           <a:p>
             <a:r>
-              <a:rPr sz="2600" b="1">
-                <a:solidFill>
-                  <a:srgbClr val="192C4C"/>
+              <a:rPr sz="2500" b="1">
+                <a:solidFill>
+                  <a:srgbClr val="182C4C"/>
                 </a:solidFill>
                 <a:latin typeface="Aptos"/>
               </a:rPr>
-              <a:t>2. System Architecture</a:t>
+              <a:t>2. Live Demo: Dashboard Output</a:t>
             </a:r>
           </a:p>
           <a:p>
             <a:r>
               <a:rPr sz="1300">
                 <a:solidFill>
-                  <a:srgbClr val="2E3846"/>
+                  <a:srgbClr val="3D4858"/>
                 </a:solidFill>
                 <a:latin typeface="Aptos"/>
               </a:rPr>
-              <a:t>The design follows a publish / subscribe model with one public MQTT broker in the center.</a:t>
-            </a:r>
-          </a:p>
-        </p:txBody>
-      </p:sp>
-      <p:sp>
-        <p:nvSpPr>
-          <p:cNvPr id="4" name="Rounded Rectangle 3"/>
+              <a:t>The screenshot below comes from the current run of subscriber_display.py.</a:t>
+            </a:r>
+          </a:p>
+        </p:txBody>
+      </p:sp>
+      <p:pic>
+        <p:nvPicPr>
+          <p:cNvPr id="4" name="Picture 3" descr="demo_dashboard.png"/>
+          <p:cNvPicPr>
+            <a:picLocks noChangeAspect="1"/>
+          </p:cNvPicPr>
+          <p:nvPr/>
+        </p:nvPicPr>
+        <p:blipFill>
+          <a:blip r:embed="rId2"/>
+          <a:stretch>
+            <a:fillRect/>
+          </a:stretch>
+        </p:blipFill>
+        <p:spPr>
+          <a:xfrm>
+            <a:off x="713232" y="1508760"/>
+            <a:ext cx="6583680" cy="4114800"/>
+          </a:xfrm>
+          <a:prstGeom prst="rect">
+            <a:avLst/>
+          </a:prstGeom>
+        </p:spPr>
+      </p:pic>
+      <p:sp>
+        <p:nvSpPr>
+          <p:cNvPr id="5" name="Rounded Rectangle 4"/>
           <p:cNvSpPr/>
           <p:nvPr/>
         </p:nvSpPr>
         <p:spPr>
           <a:xfrm>
-            <a:off x="822960" y="2011680"/>
-            <a:ext cx="2148840" cy="914400"/>
+            <a:off x="7498079" y="1600200"/>
+            <a:ext cx="4069080" cy="3931920"/>
           </a:xfrm>
           <a:prstGeom prst="roundRect">
             <a:avLst/>
           </a:prstGeom>
           <a:solidFill>
-            <a:srgbClr val="2A8F88"/>
+            <a:srgbClr val="FFFFFF"/>
           </a:solidFill>
           <a:ln>
-            <a:noFill/>
+            <a:solidFill>
+              <a:srgbClr val="E4ECF7"/>
+            </a:solidFill>
           </a:ln>
         </p:spPr>
         <p:style>
@@ -3893,52 +3975,80 @@
           <a:bodyPr rtlCol="0" anchor="ctr"/>
           <a:lstStyle/>
           <a:p>
-            <a:pPr algn="ctr">
-              <a:defRPr sz="1600" b="1">
-                <a:solidFill>
-                  <a:srgbClr val="FFFFFF"/>
+            <a:pPr algn="ctr"/>
+          </a:p>
+        </p:txBody>
+      </p:sp>
+      <p:sp>
+        <p:nvSpPr>
+          <p:cNvPr id="6" name="TextBox 5"/>
+          <p:cNvSpPr txBox="1"/>
+          <p:nvPr/>
+        </p:nvSpPr>
+        <p:spPr>
+          <a:xfrm>
+            <a:off x="7662671" y="1709928"/>
+            <a:ext cx="3739896" cy="3712463"/>
+          </a:xfrm>
+          <a:prstGeom prst="rect">
+            <a:avLst/>
+          </a:prstGeom>
+          <a:noFill/>
+        </p:spPr>
+        <p:txBody>
+          <a:bodyPr wrap="none">
+            <a:spAutoFit/>
+          </a:bodyPr>
+          <a:lstStyle/>
+          <a:p>
+            <a:pPr>
+              <a:defRPr sz="1800" b="1">
+                <a:solidFill>
+                  <a:srgbClr val="182C4C"/>
                 </a:solidFill>
                 <a:latin typeface="Aptos"/>
               </a:defRPr>
             </a:pPr>
             <a:r>
-              <a:t>Parking Sensors</a:t>
+              <a:t>What the screenshot shows</a:t>
             </a:r>
           </a:p>
           <a:p>
             <a:pPr>
-              <a:defRPr sz="1600" b="1">
-                <a:solidFill>
-                  <a:srgbClr val="FFFFFF"/>
+              <a:defRPr sz="1400">
+                <a:solidFill>
+                  <a:srgbClr val="3D4858"/>
                 </a:solidFill>
                 <a:latin typeface="Aptos"/>
               </a:defRPr>
             </a:pPr>
             <a:r>
-              <a:t>publisher_sensor.py</a:t>
-            </a:r>
-          </a:p>
-        </p:txBody>
-      </p:sp>
-      <p:sp>
-        <p:nvSpPr>
-          <p:cNvPr id="5" name="Rounded Rectangle 4"/>
+              <a:t>The dashboard is already receiving live parking slot messages and updating the visible status table. In this captured state, every slot has been reported, and the system is showing both occupied and free spaces in real time. This demonstrates that the subscription side of the prototype is functioning correctly and that the parking status topic design is usable in practice.</a:t>
+            </a:r>
+          </a:p>
+        </p:txBody>
+      </p:sp>
+      <p:sp>
+        <p:nvSpPr>
+          <p:cNvPr id="7" name="Rounded Rectangle 6"/>
           <p:cNvSpPr/>
           <p:nvPr/>
         </p:nvSpPr>
         <p:spPr>
           <a:xfrm>
-            <a:off x="822960" y="4069080"/>
-            <a:ext cx="2148840" cy="914400"/>
+            <a:off x="822960" y="5715000"/>
+            <a:ext cx="10744200" cy="658368"/>
           </a:xfrm>
           <a:prstGeom prst="roundRect">
             <a:avLst/>
           </a:prstGeom>
           <a:solidFill>
-            <a:srgbClr val="DE8539"/>
+            <a:srgbClr val="E4ECF7"/>
           </a:solidFill>
           <a:ln>
-            <a:noFill/>
+            <a:solidFill>
+              <a:srgbClr val="E4ECF7"/>
+            </a:solidFill>
           </a:ln>
         </p:spPr>
         <p:style>
@@ -3959,49 +4069,101 @@
           <a:bodyPr rtlCol="0" anchor="ctr"/>
           <a:lstStyle/>
           <a:p>
-            <a:pPr algn="ctr">
-              <a:defRPr sz="1600" b="1">
-                <a:solidFill>
-                  <a:srgbClr val="FFFFFF"/>
+            <a:pPr algn="ctr"/>
+          </a:p>
+        </p:txBody>
+      </p:sp>
+      <p:sp>
+        <p:nvSpPr>
+          <p:cNvPr id="8" name="TextBox 7"/>
+          <p:cNvSpPr txBox="1"/>
+          <p:nvPr/>
+        </p:nvSpPr>
+        <p:spPr>
+          <a:xfrm>
+            <a:off x="987552" y="5824728"/>
+            <a:ext cx="10415016" cy="438912"/>
+          </a:xfrm>
+          <a:prstGeom prst="rect">
+            <a:avLst/>
+          </a:prstGeom>
+          <a:noFill/>
+        </p:spPr>
+        <p:txBody>
+          <a:bodyPr wrap="none">
+            <a:spAutoFit/>
+          </a:bodyPr>
+          <a:lstStyle/>
+          <a:p>
+            <a:pPr>
+              <a:defRPr sz="1800" b="1">
+                <a:solidFill>
+                  <a:srgbClr val="182C4C"/>
                 </a:solidFill>
                 <a:latin typeface="Aptos"/>
               </a:defRPr>
             </a:pPr>
             <a:r>
-              <a:t>Vehicle Request Generator</a:t>
+              <a:t>Progress value</a:t>
             </a:r>
           </a:p>
           <a:p>
             <a:pPr>
-              <a:defRPr sz="1600" b="1">
-                <a:solidFill>
-                  <a:srgbClr val="FFFFFF"/>
+              <a:defRPr sz="1400">
+                <a:solidFill>
+                  <a:srgbClr val="3D4858"/>
                 </a:solidFill>
                 <a:latin typeface="Aptos"/>
               </a:defRPr>
             </a:pPr>
             <a:r>
-              <a:t>publisher_vehicle_request.py</a:t>
-            </a:r>
-          </a:p>
-        </p:txBody>
-      </p:sp>
-      <p:sp>
-        <p:nvSpPr>
-          <p:cNvPr id="6" name="Rounded Rectangle 5"/>
+              <a:t>This output proves that the project already has a working real-time monitoring view, even though it is currently implemented in the terminal instead of a graphical web page.</a:t>
+            </a:r>
+          </a:p>
+        </p:txBody>
+      </p:sp>
+    </p:spTree>
+  </p:cSld>
+  <p:clrMapOvr>
+    <a:masterClrMapping/>
+  </p:clrMapOvr>
+</p:sld>
+</file>
+
+<file path=ppt/slides/slide4.xml><?xml version="1.0" encoding="utf-8"?>
+<p:sld xmlns:a="http://schemas.openxmlformats.org/drawingml/2006/main" xmlns:p="http://schemas.openxmlformats.org/presentationml/2006/main" xmlns:r="http://schemas.openxmlformats.org/officeDocument/2006/relationships">
+  <p:cSld>
+    <p:bg>
+      <p:bgPr>
+        <a:solidFill>
+          <a:srgbClr val="F6F8FC"/>
+        </a:solidFill>
+        <a:effectLst/>
+      </p:bgPr>
+    </p:bg>
+    <p:spTree>
+      <p:nvGrpSpPr>
+        <p:cNvPr id="1" name=""/>
+        <p:cNvGrpSpPr/>
+        <p:nvPr/>
+      </p:nvGrpSpPr>
+      <p:grpSpPr/>
+      <p:sp>
+        <p:nvSpPr>
+          <p:cNvPr id="2" name="Rectangle 1"/>
           <p:cNvSpPr/>
           <p:nvPr/>
         </p:nvSpPr>
         <p:spPr>
           <a:xfrm>
-            <a:off x="4937760" y="2926080"/>
-            <a:ext cx="2148840" cy="914400"/>
-          </a:xfrm>
-          <a:prstGeom prst="roundRect">
+            <a:off x="0" y="0"/>
+            <a:ext cx="12191695" cy="384048"/>
+          </a:xfrm>
+          <a:prstGeom prst="rect">
             <a:avLst/>
           </a:prstGeom>
           <a:solidFill>
-            <a:srgbClr val="192C4C"/>
+            <a:srgbClr val="182C4C"/>
           </a:solidFill>
           <a:ln>
             <a:noFill/>
@@ -4025,52 +4187,124 @@
           <a:bodyPr rtlCol="0" anchor="ctr"/>
           <a:lstStyle/>
           <a:p>
-            <a:pPr algn="ctr">
-              <a:defRPr sz="1600" b="1">
-                <a:solidFill>
-                  <a:srgbClr val="FFFFFF"/>
+            <a:pPr algn="ctr"/>
+          </a:p>
+        </p:txBody>
+      </p:sp>
+      <p:sp>
+        <p:nvSpPr>
+          <p:cNvPr id="3" name="TextBox 2"/>
+          <p:cNvSpPr txBox="1"/>
+          <p:nvPr/>
+        </p:nvSpPr>
+        <p:spPr>
+          <a:xfrm>
+            <a:off x="640080" y="640080"/>
+            <a:ext cx="10972800" cy="822960"/>
+          </a:xfrm>
+          <a:prstGeom prst="rect">
+            <a:avLst/>
+          </a:prstGeom>
+          <a:noFill/>
+        </p:spPr>
+        <p:txBody>
+          <a:bodyPr wrap="none">
+            <a:spAutoFit/>
+          </a:bodyPr>
+          <a:lstStyle/>
+          <a:p>
+            <a:r>
+              <a:rPr sz="2500" b="1">
+                <a:solidFill>
+                  <a:srgbClr val="182C4C"/>
                 </a:solidFill>
                 <a:latin typeface="Aptos"/>
-              </a:defRPr>
-            </a:pPr>
-            <a:r>
-              <a:t>MQTT Broker</a:t>
-            </a:r>
-          </a:p>
-          <a:p>
-            <a:pPr>
-              <a:defRPr sz="1600" b="1">
-                <a:solidFill>
-                  <a:srgbClr val="FFFFFF"/>
+              </a:rPr>
+              <a:t>3. Live Demo: Message Publishing and Service Interaction</a:t>
+            </a:r>
+          </a:p>
+          <a:p>
+            <a:r>
+              <a:rPr sz="1300">
+                <a:solidFill>
+                  <a:srgbClr val="3D4858"/>
                 </a:solidFill>
                 <a:latin typeface="Aptos"/>
-              </a:defRPr>
-            </a:pPr>
-            <a:r>
-              <a:t>broker.hivemq.com</a:t>
-            </a:r>
-          </a:p>
-        </p:txBody>
-      </p:sp>
-      <p:sp>
-        <p:nvSpPr>
-          <p:cNvPr id="7" name="Rounded Rectangle 6"/>
+              </a:rPr>
+              <a:t>The current prototype already has active publishers and reactive service logic.</a:t>
+            </a:r>
+          </a:p>
+        </p:txBody>
+      </p:sp>
+      <p:pic>
+        <p:nvPicPr>
+          <p:cNvPr id="4" name="Picture 3" descr="demo_publishers.png"/>
+          <p:cNvPicPr>
+            <a:picLocks noChangeAspect="1"/>
+          </p:cNvPicPr>
+          <p:nvPr/>
+        </p:nvPicPr>
+        <p:blipFill>
+          <a:blip r:embed="rId2"/>
+          <a:stretch>
+            <a:fillRect/>
+          </a:stretch>
+        </p:blipFill>
+        <p:spPr>
+          <a:xfrm>
+            <a:off x="749808" y="1572768"/>
+            <a:ext cx="5532120" cy="3154680"/>
+          </a:xfrm>
+          <a:prstGeom prst="rect">
+            <a:avLst/>
+          </a:prstGeom>
+        </p:spPr>
+      </p:pic>
+      <p:pic>
+        <p:nvPicPr>
+          <p:cNvPr id="5" name="Picture 4" descr="demo_services.png"/>
+          <p:cNvPicPr>
+            <a:picLocks noChangeAspect="1"/>
+          </p:cNvPicPr>
+          <p:nvPr/>
+        </p:nvPicPr>
+        <p:blipFill>
+          <a:blip r:embed="rId3"/>
+          <a:stretch>
+            <a:fillRect/>
+          </a:stretch>
+        </p:blipFill>
+        <p:spPr>
+          <a:xfrm>
+            <a:off x="6355080" y="1572768"/>
+            <a:ext cx="5084064" cy="3154680"/>
+          </a:xfrm>
+          <a:prstGeom prst="rect">
+            <a:avLst/>
+          </a:prstGeom>
+        </p:spPr>
+      </p:pic>
+      <p:sp>
+        <p:nvSpPr>
+          <p:cNvPr id="6" name="Rounded Rectangle 5"/>
           <p:cNvSpPr/>
           <p:nvPr/>
         </p:nvSpPr>
         <p:spPr>
           <a:xfrm>
-            <a:off x="9189720" y="1417320"/>
-            <a:ext cx="2148840" cy="914400"/>
+            <a:off x="822960" y="4892040"/>
+            <a:ext cx="10972800" cy="1051560"/>
           </a:xfrm>
           <a:prstGeom prst="roundRect">
             <a:avLst/>
           </a:prstGeom>
           <a:solidFill>
-            <a:srgbClr val="2A8F88"/>
+            <a:srgbClr val="FFFFFF"/>
           </a:solidFill>
           <a:ln>
-            <a:noFill/>
+            <a:solidFill>
+              <a:srgbClr val="E4ECF7"/>
+            </a:solidFill>
           </a:ln>
         </p:spPr>
         <p:style>
@@ -4091,49 +4325,101 @@
           <a:bodyPr rtlCol="0" anchor="ctr"/>
           <a:lstStyle/>
           <a:p>
-            <a:pPr algn="ctr">
-              <a:defRPr sz="1600" b="1">
-                <a:solidFill>
-                  <a:srgbClr val="FFFFFF"/>
+            <a:pPr algn="ctr"/>
+          </a:p>
+        </p:txBody>
+      </p:sp>
+      <p:sp>
+        <p:nvSpPr>
+          <p:cNvPr id="7" name="TextBox 6"/>
+          <p:cNvSpPr txBox="1"/>
+          <p:nvPr/>
+        </p:nvSpPr>
+        <p:spPr>
+          <a:xfrm>
+            <a:off x="987552" y="5001768"/>
+            <a:ext cx="10643616" cy="832103"/>
+          </a:xfrm>
+          <a:prstGeom prst="rect">
+            <a:avLst/>
+          </a:prstGeom>
+          <a:noFill/>
+        </p:spPr>
+        <p:txBody>
+          <a:bodyPr wrap="none">
+            <a:spAutoFit/>
+          </a:bodyPr>
+          <a:lstStyle/>
+          <a:p>
+            <a:pPr>
+              <a:defRPr sz="1800" b="1">
+                <a:solidFill>
+                  <a:srgbClr val="182C4C"/>
                 </a:solidFill>
                 <a:latin typeface="Aptos"/>
               </a:defRPr>
             </a:pPr>
             <a:r>
-              <a:t>Display Service</a:t>
+              <a:t>Observed result</a:t>
             </a:r>
           </a:p>
           <a:p>
             <a:pPr>
-              <a:defRPr sz="1600" b="1">
-                <a:solidFill>
-                  <a:srgbClr val="FFFFFF"/>
+              <a:defRPr sz="1400">
+                <a:solidFill>
+                  <a:srgbClr val="3D4858"/>
                 </a:solidFill>
                 <a:latin typeface="Aptos"/>
               </a:defRPr>
             </a:pPr>
             <a:r>
-              <a:t>subscriber_display.py</a:t>
-            </a:r>
-          </a:p>
-        </p:txBody>
-      </p:sp>
-      <p:sp>
-        <p:nvSpPr>
-          <p:cNvPr id="8" name="Rounded Rectangle 7"/>
+              <a:t>On the left, the publishers are actively sending sensor updates and vehicle entry requests. On the right, the statistics service is continuously recalculating free spaces, and the gate controller is reacting to incoming requests by opening the gate when spaces are available. This means the project already supports a full message loop rather than isolated scripts.</a:t>
+            </a:r>
+          </a:p>
+        </p:txBody>
+      </p:sp>
+    </p:spTree>
+  </p:cSld>
+  <p:clrMapOvr>
+    <a:masterClrMapping/>
+  </p:clrMapOvr>
+</p:sld>
+</file>
+
+<file path=ppt/slides/slide5.xml><?xml version="1.0" encoding="utf-8"?>
+<p:sld xmlns:a="http://schemas.openxmlformats.org/drawingml/2006/main" xmlns:p="http://schemas.openxmlformats.org/presentationml/2006/main" xmlns:r="http://schemas.openxmlformats.org/officeDocument/2006/relationships">
+  <p:cSld>
+    <p:bg>
+      <p:bgPr>
+        <a:solidFill>
+          <a:srgbClr val="F6F8FC"/>
+        </a:solidFill>
+        <a:effectLst/>
+      </p:bgPr>
+    </p:bg>
+    <p:spTree>
+      <p:nvGrpSpPr>
+        <p:cNvPr id="1" name=""/>
+        <p:cNvGrpSpPr/>
+        <p:nvPr/>
+      </p:nvGrpSpPr>
+      <p:grpSpPr/>
+      <p:sp>
+        <p:nvSpPr>
+          <p:cNvPr id="2" name="Rectangle 1"/>
           <p:cNvSpPr/>
           <p:nvPr/>
         </p:nvSpPr>
         <p:spPr>
           <a:xfrm>
-            <a:off x="9189720" y="2926080"/>
-            <a:ext cx="2148840" cy="914400"/>
-          </a:xfrm>
-          <a:prstGeom prst="roundRect">
+            <a:off x="0" y="0"/>
+            <a:ext cx="12191695" cy="384048"/>
+          </a:xfrm>
+          <a:prstGeom prst="rect">
             <a:avLst/>
           </a:prstGeom>
           <a:solidFill>
-            <a:srgbClr val="DE8539"/>
+            <a:srgbClr val="182C4C"/>
           </a:solidFill>
           <a:ln>
             <a:noFill/>
@@ -4157,52 +4443,100 @@
           <a:bodyPr rtlCol="0" anchor="ctr"/>
           <a:lstStyle/>
           <a:p>
-            <a:pPr algn="ctr">
-              <a:defRPr sz="1600" b="1">
-                <a:solidFill>
-                  <a:srgbClr val="FFFFFF"/>
+            <a:pPr algn="ctr"/>
+          </a:p>
+        </p:txBody>
+      </p:sp>
+      <p:sp>
+        <p:nvSpPr>
+          <p:cNvPr id="3" name="TextBox 2"/>
+          <p:cNvSpPr txBox="1"/>
+          <p:nvPr/>
+        </p:nvSpPr>
+        <p:spPr>
+          <a:xfrm>
+            <a:off x="640080" y="640080"/>
+            <a:ext cx="10972800" cy="822960"/>
+          </a:xfrm>
+          <a:prstGeom prst="rect">
+            <a:avLst/>
+          </a:prstGeom>
+          <a:noFill/>
+        </p:spPr>
+        <p:txBody>
+          <a:bodyPr wrap="none">
+            <a:spAutoFit/>
+          </a:bodyPr>
+          <a:lstStyle/>
+          <a:p>
+            <a:r>
+              <a:rPr sz="2500" b="1">
+                <a:solidFill>
+                  <a:srgbClr val="182C4C"/>
                 </a:solidFill>
                 <a:latin typeface="Aptos"/>
-              </a:defRPr>
-            </a:pPr>
-            <a:r>
-              <a:t>Statistics Service</a:t>
-            </a:r>
-          </a:p>
-          <a:p>
-            <a:pPr>
-              <a:defRPr sz="1600" b="1">
-                <a:solidFill>
-                  <a:srgbClr val="FFFFFF"/>
+              </a:rPr>
+              <a:t>4. GitHub Progress and Commit Record</a:t>
+            </a:r>
+          </a:p>
+          <a:p>
+            <a:r>
+              <a:rPr sz="1300">
+                <a:solidFill>
+                  <a:srgbClr val="3D4858"/>
                 </a:solidFill>
                 <a:latin typeface="Aptos"/>
-              </a:defRPr>
-            </a:pPr>
-            <a:r>
-              <a:t>subscriber_stats.py</a:t>
-            </a:r>
-          </a:p>
-        </p:txBody>
-      </p:sp>
-      <p:sp>
-        <p:nvSpPr>
-          <p:cNvPr id="9" name="Rounded Rectangle 8"/>
+              </a:rPr>
+              <a:t>The repository history now reflects the recent implementation and presentation work.</a:t>
+            </a:r>
+          </a:p>
+        </p:txBody>
+      </p:sp>
+      <p:pic>
+        <p:nvPicPr>
+          <p:cNvPr id="4" name="Picture 3" descr="github_commits_framed.png"/>
+          <p:cNvPicPr>
+            <a:picLocks noChangeAspect="1"/>
+          </p:cNvPicPr>
+          <p:nvPr/>
+        </p:nvPicPr>
+        <p:blipFill>
+          <a:blip r:embed="rId2"/>
+          <a:stretch>
+            <a:fillRect/>
+          </a:stretch>
+        </p:blipFill>
+        <p:spPr>
+          <a:xfrm>
+            <a:off x="658368" y="1417320"/>
+            <a:ext cx="7589520" cy="4800600"/>
+          </a:xfrm>
+          <a:prstGeom prst="rect">
+            <a:avLst/>
+          </a:prstGeom>
+        </p:spPr>
+      </p:pic>
+      <p:sp>
+        <p:nvSpPr>
+          <p:cNvPr id="5" name="Rounded Rectangle 4"/>
           <p:cNvSpPr/>
           <p:nvPr/>
         </p:nvSpPr>
         <p:spPr>
           <a:xfrm>
-            <a:off x="9189720" y="4434840"/>
-            <a:ext cx="2148840" cy="914400"/>
+            <a:off x="8458200" y="1600200"/>
+            <a:ext cx="3063240" cy="4206240"/>
           </a:xfrm>
           <a:prstGeom prst="roundRect">
             <a:avLst/>
           </a:prstGeom>
           <a:solidFill>
-            <a:srgbClr val="2A8F88"/>
+            <a:srgbClr val="FFFFFF"/>
           </a:solidFill>
           <a:ln>
-            <a:noFill/>
+            <a:solidFill>
+              <a:srgbClr val="E4ECF7"/>
+            </a:solidFill>
           </a:ln>
         </p:spPr>
         <p:style>
@@ -4223,43 +4557,20 @@
           <a:bodyPr rtlCol="0" anchor="ctr"/>
           <a:lstStyle/>
           <a:p>
-            <a:pPr algn="ctr">
-              <a:defRPr sz="1600" b="1">
-                <a:solidFill>
-                  <a:srgbClr val="FFFFFF"/>
-                </a:solidFill>
-                <a:latin typeface="Aptos"/>
-              </a:defRPr>
-            </a:pPr>
-            <a:r>
-              <a:t>Gate Controller</a:t>
-            </a:r>
-          </a:p>
-          <a:p>
-            <a:pPr>
-              <a:defRPr sz="1600" b="1">
-                <a:solidFill>
-                  <a:srgbClr val="FFFFFF"/>
-                </a:solidFill>
-                <a:latin typeface="Aptos"/>
-              </a:defRPr>
-            </a:pPr>
-            <a:r>
-              <a:t>subscriber_gateway.py</a:t>
-            </a:r>
-          </a:p>
-        </p:txBody>
-      </p:sp>
-      <p:sp>
-        <p:nvSpPr>
-          <p:cNvPr id="10" name="TextBox 9"/>
+            <a:pPr algn="ctr"/>
+          </a:p>
+        </p:txBody>
+      </p:sp>
+      <p:sp>
+        <p:nvSpPr>
+          <p:cNvPr id="6" name="TextBox 5"/>
           <p:cNvSpPr txBox="1"/>
           <p:nvPr/>
         </p:nvSpPr>
         <p:spPr>
           <a:xfrm>
-            <a:off x="3383280" y="2240280"/>
-            <a:ext cx="365760" cy="365760"/>
+            <a:off x="8622792" y="1709928"/>
+            <a:ext cx="2734056" cy="3986783"/>
           </a:xfrm>
           <a:prstGeom prst="rect">
             <a:avLst/>
@@ -4272,170 +4583,126 @@
           </a:bodyPr>
           <a:lstStyle/>
           <a:p>
-            <a:pPr algn="ctr"/>
-            <a:r>
-              <a:rPr sz="2600" b="1">
-                <a:solidFill>
-                  <a:srgbClr val="192C4C"/>
-                </a:solidFill>
-              </a:rPr>
-              <a:t>→</a:t>
-            </a:r>
-          </a:p>
-        </p:txBody>
-      </p:sp>
-      <p:sp>
-        <p:nvSpPr>
-          <p:cNvPr id="11" name="TextBox 10"/>
-          <p:cNvSpPr txBox="1"/>
+            <a:pPr>
+              <a:defRPr sz="1800" b="1">
+                <a:solidFill>
+                  <a:srgbClr val="182C4C"/>
+                </a:solidFill>
+                <a:latin typeface="Aptos"/>
+              </a:defRPr>
+            </a:pPr>
+            <a:r>
+              <a:t>Repository progress</a:t>
+            </a:r>
+          </a:p>
+          <a:p>
+            <a:pPr>
+              <a:spcAft>
+                <a:spcPts val="400"/>
+              </a:spcAft>
+              <a:defRPr sz="1400">
+                <a:solidFill>
+                  <a:srgbClr val="3D4858"/>
+                </a:solidFill>
+                <a:latin typeface="Aptos"/>
+              </a:defRPr>
+            </a:pPr>
+            <a:r>
+              <a:t>The latest branch already contains the prototype improvements and the presentation files.</a:t>
+            </a:r>
+          </a:p>
+          <a:p>
+            <a:pPr>
+              <a:spcAft>
+                <a:spcPts val="400"/>
+              </a:spcAft>
+              <a:defRPr sz="1400">
+                <a:solidFill>
+                  <a:srgbClr val="3D4858"/>
+                </a:solidFill>
+                <a:latin typeface="Aptos"/>
+              </a:defRPr>
+            </a:pPr>
+            <a:r>
+              <a:t>The commit history shows that the work was recorded step by step instead of only being kept locally.</a:t>
+            </a:r>
+          </a:p>
+          <a:p>
+            <a:pPr>
+              <a:spcAft>
+                <a:spcPts val="400"/>
+              </a:spcAft>
+              <a:defRPr sz="1400">
+                <a:solidFill>
+                  <a:srgbClr val="3D4858"/>
+                </a:solidFill>
+                <a:latin typeface="Aptos"/>
+              </a:defRPr>
+            </a:pPr>
+            <a:r>
+              <a:t>This is useful for collaboration because team members can review the exact changes made to the project.</a:t>
+            </a:r>
+          </a:p>
+          <a:p>
+            <a:pPr>
+              <a:spcAft>
+                <a:spcPts val="400"/>
+              </a:spcAft>
+              <a:defRPr sz="1400">
+                <a:solidFill>
+                  <a:srgbClr val="3D4858"/>
+                </a:solidFill>
+                <a:latin typeface="Aptos"/>
+              </a:defRPr>
+            </a:pPr>
+            <a:r>
+              <a:t>The branch can now be used as a clean checkpoint for the next round of development.</a:t>
+            </a:r>
+          </a:p>
+        </p:txBody>
+      </p:sp>
+    </p:spTree>
+  </p:cSld>
+  <p:clrMapOvr>
+    <a:masterClrMapping/>
+  </p:clrMapOvr>
+</p:sld>
+</file>
+
+<file path=ppt/slides/slide6.xml><?xml version="1.0" encoding="utf-8"?>
+<p:sld xmlns:a="http://schemas.openxmlformats.org/drawingml/2006/main" xmlns:p="http://schemas.openxmlformats.org/presentationml/2006/main" xmlns:r="http://schemas.openxmlformats.org/officeDocument/2006/relationships">
+  <p:cSld>
+    <p:bg>
+      <p:bgPr>
+        <a:solidFill>
+          <a:srgbClr val="F6F8FC"/>
+        </a:solidFill>
+        <a:effectLst/>
+      </p:bgPr>
+    </p:bg>
+    <p:spTree>
+      <p:nvGrpSpPr>
+        <p:cNvPr id="1" name=""/>
+        <p:cNvGrpSpPr/>
+        <p:nvPr/>
+      </p:nvGrpSpPr>
+      <p:grpSpPr/>
+      <p:sp>
+        <p:nvSpPr>
+          <p:cNvPr id="2" name="Rectangle 1"/>
+          <p:cNvSpPr/>
           <p:nvPr/>
         </p:nvSpPr>
         <p:spPr>
           <a:xfrm>
-            <a:off x="3383280" y="4297680"/>
-            <a:ext cx="365760" cy="365760"/>
+            <a:off x="0" y="0"/>
+            <a:ext cx="12191695" cy="384048"/>
           </a:xfrm>
           <a:prstGeom prst="rect">
             <a:avLst/>
           </a:prstGeom>
-          <a:noFill/>
-        </p:spPr>
-        <p:txBody>
-          <a:bodyPr wrap="none">
-            <a:spAutoFit/>
-          </a:bodyPr>
-          <a:lstStyle/>
-          <a:p>
-            <a:pPr algn="ctr"/>
-            <a:r>
-              <a:rPr sz="2600" b="1">
-                <a:solidFill>
-                  <a:srgbClr val="192C4C"/>
-                </a:solidFill>
-              </a:rPr>
-              <a:t>→</a:t>
-            </a:r>
-          </a:p>
-        </p:txBody>
-      </p:sp>
-      <p:sp>
-        <p:nvSpPr>
-          <p:cNvPr id="12" name="TextBox 11"/>
-          <p:cNvSpPr txBox="1"/>
-          <p:nvPr/>
-        </p:nvSpPr>
-        <p:spPr>
-          <a:xfrm>
-            <a:off x="8001000" y="1737360"/>
-            <a:ext cx="365760" cy="365760"/>
-          </a:xfrm>
-          <a:prstGeom prst="rect">
-            <a:avLst/>
-          </a:prstGeom>
-          <a:noFill/>
-        </p:spPr>
-        <p:txBody>
-          <a:bodyPr wrap="none">
-            <a:spAutoFit/>
-          </a:bodyPr>
-          <a:lstStyle/>
-          <a:p>
-            <a:pPr algn="ctr"/>
-            <a:r>
-              <a:rPr sz="2600" b="1">
-                <a:solidFill>
-                  <a:srgbClr val="192C4C"/>
-                </a:solidFill>
-              </a:rPr>
-              <a:t>→</a:t>
-            </a:r>
-          </a:p>
-        </p:txBody>
-      </p:sp>
-      <p:sp>
-        <p:nvSpPr>
-          <p:cNvPr id="13" name="TextBox 12"/>
-          <p:cNvSpPr txBox="1"/>
-          <p:nvPr/>
-        </p:nvSpPr>
-        <p:spPr>
-          <a:xfrm>
-            <a:off x="8001000" y="3246120"/>
-            <a:ext cx="365760" cy="365760"/>
-          </a:xfrm>
-          <a:prstGeom prst="rect">
-            <a:avLst/>
-          </a:prstGeom>
-          <a:noFill/>
-        </p:spPr>
-        <p:txBody>
-          <a:bodyPr wrap="none">
-            <a:spAutoFit/>
-          </a:bodyPr>
-          <a:lstStyle/>
-          <a:p>
-            <a:pPr algn="ctr"/>
-            <a:r>
-              <a:rPr sz="2600" b="1">
-                <a:solidFill>
-                  <a:srgbClr val="192C4C"/>
-                </a:solidFill>
-              </a:rPr>
-              <a:t>→</a:t>
-            </a:r>
-          </a:p>
-        </p:txBody>
-      </p:sp>
-      <p:sp>
-        <p:nvSpPr>
-          <p:cNvPr id="14" name="TextBox 13"/>
-          <p:cNvSpPr txBox="1"/>
-          <p:nvPr/>
-        </p:nvSpPr>
-        <p:spPr>
-          <a:xfrm>
-            <a:off x="8001000" y="4754880"/>
-            <a:ext cx="365760" cy="365760"/>
-          </a:xfrm>
-          <a:prstGeom prst="rect">
-            <a:avLst/>
-          </a:prstGeom>
-          <a:noFill/>
-        </p:spPr>
-        <p:txBody>
-          <a:bodyPr wrap="none">
-            <a:spAutoFit/>
-          </a:bodyPr>
-          <a:lstStyle/>
-          <a:p>
-            <a:pPr algn="ctr"/>
-            <a:r>
-              <a:rPr sz="2600" b="1">
-                <a:solidFill>
-                  <a:srgbClr val="192C4C"/>
-                </a:solidFill>
-              </a:rPr>
-              <a:t>→</a:t>
-            </a:r>
-          </a:p>
-        </p:txBody>
-      </p:sp>
-      <p:sp>
-        <p:nvSpPr>
-          <p:cNvPr id="15" name="Rounded Rectangle 14"/>
-          <p:cNvSpPr/>
-          <p:nvPr/>
-        </p:nvSpPr>
-        <p:spPr>
-          <a:xfrm>
-            <a:off x="868680" y="5486400"/>
-            <a:ext cx="10515600" cy="731520"/>
-          </a:xfrm>
-          <a:prstGeom prst="roundRect">
-            <a:avLst/>
-          </a:prstGeom>
           <a:solidFill>
-            <a:srgbClr val="E4ECF7"/>
+            <a:srgbClr val="182C4C"/>
           </a:solidFill>
           <a:ln>
             <a:noFill/>
@@ -4465,14 +4732,14 @@
       </p:sp>
       <p:sp>
         <p:nvSpPr>
-          <p:cNvPr id="16" name="TextBox 15"/>
+          <p:cNvPr id="3" name="TextBox 2"/>
           <p:cNvSpPr txBox="1"/>
           <p:nvPr/>
         </p:nvSpPr>
         <p:spPr>
           <a:xfrm>
-            <a:off x="1033271" y="5596128"/>
-            <a:ext cx="10186416" cy="512064"/>
+            <a:off x="640080" y="640080"/>
+            <a:ext cx="10972800" cy="822960"/>
           </a:xfrm>
           <a:prstGeom prst="rect">
             <a:avLst/>
@@ -4480,73 +4747,55 @@
           <a:noFill/>
         </p:spPr>
         <p:txBody>
-          <a:bodyPr wrap="square" anchor="t">
+          <a:bodyPr wrap="none">
             <a:spAutoFit/>
           </a:bodyPr>
           <a:lstStyle/>
           <a:p>
-            <a:pPr>
-              <a:spcAft>
-                <a:spcPts val="600"/>
-              </a:spcAft>
-              <a:defRPr sz="1400" b="0">
-                <a:solidFill>
-                  <a:srgbClr val="192C4C"/>
+            <a:r>
+              <a:rPr sz="2500" b="1">
+                <a:solidFill>
+                  <a:srgbClr val="182C4C"/>
                 </a:solidFill>
                 <a:latin typeface="Aptos"/>
-              </a:defRPr>
-            </a:pPr>
-            <a:r>
-              <a:t>The architecture separates data producers from data consumers. Parking sensors publish slot status messages. A second publisher simulates vehicle arrival requests at the entrance. The display service subscribes to all parking updates and shows the latest state. The statistics service calculates how many spaces are free and publishes a summary. The gate controller listens to both the vehicle request topic and the statistics topic, then decides whether to allow a car to enter. This structure keeps the system modular and easy to extend.</a:t>
-            </a:r>
-          </a:p>
-        </p:txBody>
-      </p:sp>
-    </p:spTree>
-  </p:cSld>
-  <p:clrMapOvr>
-    <a:masterClrMapping/>
-  </p:clrMapOvr>
-</p:sld>
-</file>
-
-<file path=ppt/slides/slide4.xml><?xml version="1.0" encoding="utf-8"?>
-<p:sld xmlns:a="http://schemas.openxmlformats.org/drawingml/2006/main" xmlns:p="http://schemas.openxmlformats.org/presentationml/2006/main" xmlns:r="http://schemas.openxmlformats.org/officeDocument/2006/relationships">
-  <p:cSld>
-    <p:bg>
-      <p:bgPr>
-        <a:solidFill>
-          <a:srgbClr val="F7F9FC"/>
-        </a:solidFill>
-        <a:effectLst/>
-      </p:bgPr>
-    </p:bg>
-    <p:spTree>
-      <p:nvGrpSpPr>
-        <p:cNvPr id="1" name=""/>
-        <p:cNvGrpSpPr/>
-        <p:nvPr/>
-      </p:nvGrpSpPr>
-      <p:grpSpPr/>
-      <p:sp>
-        <p:nvSpPr>
-          <p:cNvPr id="2" name="Rectangle 1"/>
+              </a:rPr>
+              <a:t>5. Current Status and Next Step</a:t>
+            </a:r>
+          </a:p>
+          <a:p>
+            <a:r>
+              <a:rPr sz="1300">
+                <a:solidFill>
+                  <a:srgbClr val="3D4858"/>
+                </a:solidFill>
+                <a:latin typeface="Aptos"/>
+              </a:rPr>
+              <a:t>The prototype is already ready for a short classroom demonstration.</a:t>
+            </a:r>
+          </a:p>
+        </p:txBody>
+      </p:sp>
+      <p:sp>
+        <p:nvSpPr>
+          <p:cNvPr id="4" name="Rounded Rectangle 3"/>
           <p:cNvSpPr/>
           <p:nvPr/>
         </p:nvSpPr>
         <p:spPr>
           <a:xfrm>
-            <a:off x="0" y="0"/>
-            <a:ext cx="12191695" cy="411480"/>
-          </a:xfrm>
-          <a:prstGeom prst="rect">
+            <a:off x="777240" y="1691640"/>
+            <a:ext cx="5212080" cy="4389120"/>
+          </a:xfrm>
+          <a:prstGeom prst="roundRect">
             <a:avLst/>
           </a:prstGeom>
           <a:solidFill>
-            <a:srgbClr val="192C4C"/>
+            <a:srgbClr val="FFFFFF"/>
           </a:solidFill>
           <a:ln>
-            <a:noFill/>
+            <a:solidFill>
+              <a:srgbClr val="E4ECF7"/>
+            </a:solidFill>
           </a:ln>
         </p:spPr>
         <p:style>
@@ -4573,14 +4822,14 @@
       </p:sp>
       <p:sp>
         <p:nvSpPr>
-          <p:cNvPr id="3" name="TextBox 2"/>
+          <p:cNvPr id="5" name="TextBox 4"/>
           <p:cNvSpPr txBox="1"/>
           <p:nvPr/>
         </p:nvSpPr>
         <p:spPr>
           <a:xfrm>
-            <a:off x="640080" y="658368"/>
-            <a:ext cx="10972800" cy="822960"/>
+            <a:off x="941832" y="1801368"/>
+            <a:ext cx="4882896" cy="4169663"/>
           </a:xfrm>
           <a:prstGeom prst="rect">
             <a:avLst/>
@@ -4588,524 +4837,110 @@
           <a:noFill/>
         </p:spPr>
         <p:txBody>
-          <a:bodyPr wrap="square">
+          <a:bodyPr wrap="none">
             <a:spAutoFit/>
           </a:bodyPr>
           <a:lstStyle/>
           <a:p>
-            <a:r>
-              <a:rPr sz="2600" b="1">
-                <a:solidFill>
-                  <a:srgbClr val="192C4C"/>
+            <a:pPr>
+              <a:defRPr sz="1800" b="1">
+                <a:solidFill>
+                  <a:srgbClr val="182C4C"/>
                 </a:solidFill>
                 <a:latin typeface="Aptos"/>
-              </a:rPr>
-              <a:t>3. MQTT Topics and Data Flow</a:t>
-            </a:r>
-          </a:p>
-          <a:p>
-            <a:r>
-              <a:rPr sz="1300">
-                <a:solidFill>
-                  <a:srgbClr val="2E3846"/>
+              </a:defRPr>
+            </a:pPr>
+            <a:r>
+              <a:t>What is ready now</a:t>
+            </a:r>
+          </a:p>
+          <a:p>
+            <a:pPr>
+              <a:spcAft>
+                <a:spcPts val="400"/>
+              </a:spcAft>
+              <a:defRPr sz="1400">
+                <a:solidFill>
+                  <a:srgbClr val="3D4858"/>
                 </a:solidFill>
                 <a:latin typeface="Aptos"/>
-              </a:rPr>
-              <a:t>Each topic has a clear responsibility so that the message flow remains easy to understand.</a:t>
-            </a:r>
-          </a:p>
-        </p:txBody>
-      </p:sp>
-      <p:graphicFrame>
-        <p:nvGraphicFramePr>
-          <p:cNvPr id="4" name="Table 3"/>
-          <p:cNvGraphicFramePr>
-            <a:graphicFrameLocks noGrp="1"/>
-          </p:cNvGraphicFramePr>
-          <p:nvPr/>
-        </p:nvGraphicFramePr>
-        <p:xfrm>
-          <a:off x="822960" y="1645920"/>
-          <a:ext cx="10515600" cy="3291840"/>
-        </p:xfrm>
-        <a:graphic>
-          <a:graphicData uri="http://schemas.openxmlformats.org/drawingml/2006/table">
-            <a:tbl>
-              <a:tblPr firstRow="1" bandRow="1">
-                <a:tableStyleId>{5C22544A-7EE6-4342-B048-85BDC9FD1C3A}</a:tableStyleId>
-              </a:tblPr>
-              <a:tblGrid>
-                <a:gridCol w="3505200"/>
-                <a:gridCol w="3505200"/>
-                <a:gridCol w="3505200"/>
-              </a:tblGrid>
-              <a:tr h="548640">
-                <a:tc>
-                  <a:txBody>
-                    <a:bodyPr/>
-                    <a:lstStyle/>
-                    <a:p>
-                      <a:pPr>
-                        <a:defRPr sz="1600" b="1">
-                          <a:solidFill>
-                            <a:srgbClr val="FFFFFF"/>
-                          </a:solidFill>
-                          <a:latin typeface="Aptos"/>
-                        </a:defRPr>
-                      </a:pPr>
-                      <a:r>
-                        <a:t>Topic</a:t>
-                      </a:r>
-                    </a:p>
-                  </a:txBody>
-                  <a:tcPr>
-                    <a:solidFill>
-                      <a:srgbClr val="192C4C"/>
-                    </a:solidFill>
-                  </a:tcPr>
-                </a:tc>
-                <a:tc>
-                  <a:txBody>
-                    <a:bodyPr/>
-                    <a:lstStyle/>
-                    <a:p>
-                      <a:pPr>
-                        <a:defRPr sz="1600" b="1">
-                          <a:solidFill>
-                            <a:srgbClr val="FFFFFF"/>
-                          </a:solidFill>
-                          <a:latin typeface="Aptos"/>
-                        </a:defRPr>
-                      </a:pPr>
-                      <a:r>
-                        <a:t>Publisher</a:t>
-                      </a:r>
-                    </a:p>
-                  </a:txBody>
-                  <a:tcPr>
-                    <a:solidFill>
-                      <a:srgbClr val="192C4C"/>
-                    </a:solidFill>
-                  </a:tcPr>
-                </a:tc>
-                <a:tc>
-                  <a:txBody>
-                    <a:bodyPr/>
-                    <a:lstStyle/>
-                    <a:p>
-                      <a:pPr>
-                        <a:defRPr sz="1600" b="1">
-                          <a:solidFill>
-                            <a:srgbClr val="FFFFFF"/>
-                          </a:solidFill>
-                          <a:latin typeface="Aptos"/>
-                        </a:defRPr>
-                      </a:pPr>
-                      <a:r>
-                        <a:t>Purpose</a:t>
-                      </a:r>
-                    </a:p>
-                  </a:txBody>
-                  <a:tcPr>
-                    <a:solidFill>
-                      <a:srgbClr val="192C4C"/>
-                    </a:solidFill>
-                  </a:tcPr>
-                </a:tc>
-              </a:tr>
-              <a:tr h="548640">
-                <a:tc>
-                  <a:txBody>
-                    <a:bodyPr/>
-                    <a:lstStyle/>
-                    <a:p>
-                      <a:pPr>
-                        <a:defRPr sz="1300">
-                          <a:solidFill>
-                            <a:srgbClr val="2E3846"/>
-                          </a:solidFill>
-                          <a:latin typeface="Aptos"/>
-                        </a:defRPr>
-                      </a:pPr>
-                      <a:r>
-                        <a:t>parking/lot/A01/status</a:t>
-                      </a:r>
-                    </a:p>
-                  </a:txBody>
-                  <a:tcPr>
-                    <a:solidFill>
-                      <a:srgbClr val="FFFFFF"/>
-                    </a:solidFill>
-                  </a:tcPr>
-                </a:tc>
-                <a:tc>
-                  <a:txBody>
-                    <a:bodyPr/>
-                    <a:lstStyle/>
-                    <a:p>
-                      <a:pPr>
-                        <a:defRPr sz="1300">
-                          <a:solidFill>
-                            <a:srgbClr val="2E3846"/>
-                          </a:solidFill>
-                          <a:latin typeface="Aptos"/>
-                        </a:defRPr>
-                      </a:pPr>
-                      <a:r>
-                        <a:t>Parking sensors</a:t>
-                      </a:r>
-                    </a:p>
-                  </a:txBody>
-                  <a:tcPr>
-                    <a:solidFill>
-                      <a:srgbClr val="FFFFFF"/>
-                    </a:solidFill>
-                  </a:tcPr>
-                </a:tc>
-                <a:tc>
-                  <a:txBody>
-                    <a:bodyPr/>
-                    <a:lstStyle/>
-                    <a:p>
-                      <a:pPr>
-                        <a:defRPr sz="1300">
-                          <a:solidFill>
-                            <a:srgbClr val="2E3846"/>
-                          </a:solidFill>
-                          <a:latin typeface="Aptos"/>
-                        </a:defRPr>
-                      </a:pPr>
-                      <a:r>
-                        <a:t>Publishes the current state of one specific parking slot.</a:t>
-                      </a:r>
-                    </a:p>
-                  </a:txBody>
-                  <a:tcPr>
-                    <a:solidFill>
-                      <a:srgbClr val="FFFFFF"/>
-                    </a:solidFill>
-                  </a:tcPr>
-                </a:tc>
-              </a:tr>
-              <a:tr h="548640">
-                <a:tc>
-                  <a:txBody>
-                    <a:bodyPr/>
-                    <a:lstStyle/>
-                    <a:p>
-                      <a:pPr>
-                        <a:defRPr sz="1300">
-                          <a:solidFill>
-                            <a:srgbClr val="2E3846"/>
-                          </a:solidFill>
-                          <a:latin typeface="Aptos"/>
-                        </a:defRPr>
-                      </a:pPr>
-                      <a:r>
-                        <a:t>parking/lot/+/status</a:t>
-                      </a:r>
-                    </a:p>
-                  </a:txBody>
-                  <a:tcPr>
-                    <a:solidFill>
-                      <a:srgbClr val="FFFFFF"/>
-                    </a:solidFill>
-                  </a:tcPr>
-                </a:tc>
-                <a:tc>
-                  <a:txBody>
-                    <a:bodyPr/>
-                    <a:lstStyle/>
-                    <a:p>
-                      <a:pPr>
-                        <a:defRPr sz="1300">
-                          <a:solidFill>
-                            <a:srgbClr val="2E3846"/>
-                          </a:solidFill>
-                          <a:latin typeface="Aptos"/>
-                        </a:defRPr>
-                      </a:pPr>
-                      <a:r>
-                        <a:t>All parking sensors</a:t>
-                      </a:r>
-                    </a:p>
-                  </a:txBody>
-                  <a:tcPr>
-                    <a:solidFill>
-                      <a:srgbClr val="FFFFFF"/>
-                    </a:solidFill>
-                  </a:tcPr>
-                </a:tc>
-                <a:tc>
-                  <a:txBody>
-                    <a:bodyPr/>
-                    <a:lstStyle/>
-                    <a:p>
-                      <a:pPr>
-                        <a:defRPr sz="1300">
-                          <a:solidFill>
-                            <a:srgbClr val="2E3846"/>
-                          </a:solidFill>
-                          <a:latin typeface="Aptos"/>
-                        </a:defRPr>
-                      </a:pPr>
-                      <a:r>
-                        <a:t>Allows subscribers to receive updates from all parking slots.</a:t>
-                      </a:r>
-                    </a:p>
-                  </a:txBody>
-                  <a:tcPr>
-                    <a:solidFill>
-                      <a:srgbClr val="FFFFFF"/>
-                    </a:solidFill>
-                  </a:tcPr>
-                </a:tc>
-              </a:tr>
-              <a:tr h="548640">
-                <a:tc>
-                  <a:txBody>
-                    <a:bodyPr/>
-                    <a:lstStyle/>
-                    <a:p>
-                      <a:pPr>
-                        <a:defRPr sz="1300">
-                          <a:solidFill>
-                            <a:srgbClr val="2E3846"/>
-                          </a:solidFill>
-                          <a:latin typeface="Aptos"/>
-                        </a:defRPr>
-                      </a:pPr>
-                      <a:r>
-                        <a:t>parking/stats/summary</a:t>
-                      </a:r>
-                    </a:p>
-                  </a:txBody>
-                  <a:tcPr>
-                    <a:solidFill>
-                      <a:srgbClr val="FFFFFF"/>
-                    </a:solidFill>
-                  </a:tcPr>
-                </a:tc>
-                <a:tc>
-                  <a:txBody>
-                    <a:bodyPr/>
-                    <a:lstStyle/>
-                    <a:p>
-                      <a:pPr>
-                        <a:defRPr sz="1300">
-                          <a:solidFill>
-                            <a:srgbClr val="2E3846"/>
-                          </a:solidFill>
-                          <a:latin typeface="Aptos"/>
-                        </a:defRPr>
-                      </a:pPr>
-                      <a:r>
-                        <a:t>Statistics service</a:t>
-                      </a:r>
-                    </a:p>
-                  </a:txBody>
-                  <a:tcPr>
-                    <a:solidFill>
-                      <a:srgbClr val="FFFFFF"/>
-                    </a:solidFill>
-                  </a:tcPr>
-                </a:tc>
-                <a:tc>
-                  <a:txBody>
-                    <a:bodyPr/>
-                    <a:lstStyle/>
-                    <a:p>
-                      <a:pPr>
-                        <a:defRPr sz="1300">
-                          <a:solidFill>
-                            <a:srgbClr val="2E3846"/>
-                          </a:solidFill>
-                          <a:latin typeface="Aptos"/>
-                        </a:defRPr>
-                      </a:pPr>
-                      <a:r>
-                        <a:t>Sends the total number of free and occupied slots.</a:t>
-                      </a:r>
-                    </a:p>
-                  </a:txBody>
-                  <a:tcPr>
-                    <a:solidFill>
-                      <a:srgbClr val="FFFFFF"/>
-                    </a:solidFill>
-                  </a:tcPr>
-                </a:tc>
-              </a:tr>
-              <a:tr h="548640">
-                <a:tc>
-                  <a:txBody>
-                    <a:bodyPr/>
-                    <a:lstStyle/>
-                    <a:p>
-                      <a:pPr>
-                        <a:defRPr sz="1300">
-                          <a:solidFill>
-                            <a:srgbClr val="2E3846"/>
-                          </a:solidFill>
-                          <a:latin typeface="Aptos"/>
-                        </a:defRPr>
-                      </a:pPr>
-                      <a:r>
-                        <a:t>parking/gate/request</a:t>
-                      </a:r>
-                    </a:p>
-                  </a:txBody>
-                  <a:tcPr>
-                    <a:solidFill>
-                      <a:srgbClr val="FFFFFF"/>
-                    </a:solidFill>
-                  </a:tcPr>
-                </a:tc>
-                <a:tc>
-                  <a:txBody>
-                    <a:bodyPr/>
-                    <a:lstStyle/>
-                    <a:p>
-                      <a:pPr>
-                        <a:defRPr sz="1300">
-                          <a:solidFill>
-                            <a:srgbClr val="2E3846"/>
-                          </a:solidFill>
-                          <a:latin typeface="Aptos"/>
-                        </a:defRPr>
-                      </a:pPr>
-                      <a:r>
-                        <a:t>Vehicle request generator</a:t>
-                      </a:r>
-                    </a:p>
-                  </a:txBody>
-                  <a:tcPr>
-                    <a:solidFill>
-                      <a:srgbClr val="FFFFFF"/>
-                    </a:solidFill>
-                  </a:tcPr>
-                </a:tc>
-                <a:tc>
-                  <a:txBody>
-                    <a:bodyPr/>
-                    <a:lstStyle/>
-                    <a:p>
-                      <a:pPr>
-                        <a:defRPr sz="1300">
-                          <a:solidFill>
-                            <a:srgbClr val="2E3846"/>
-                          </a:solidFill>
-                          <a:latin typeface="Aptos"/>
-                        </a:defRPr>
-                      </a:pPr>
-                      <a:r>
-                        <a:t>Represents a car asking to enter the parking area.</a:t>
-                      </a:r>
-                    </a:p>
-                  </a:txBody>
-                  <a:tcPr>
-                    <a:solidFill>
-                      <a:srgbClr val="FFFFFF"/>
-                    </a:solidFill>
-                  </a:tcPr>
-                </a:tc>
-              </a:tr>
-              <a:tr h="548640">
-                <a:tc>
-                  <a:txBody>
-                    <a:bodyPr/>
-                    <a:lstStyle/>
-                    <a:p>
-                      <a:pPr>
-                        <a:defRPr sz="1300">
-                          <a:solidFill>
-                            <a:srgbClr val="2E3846"/>
-                          </a:solidFill>
-                          <a:latin typeface="Aptos"/>
-                        </a:defRPr>
-                      </a:pPr>
-                      <a:r>
-                        <a:t>parking/gate/entry</a:t>
-                      </a:r>
-                    </a:p>
-                  </a:txBody>
-                  <a:tcPr>
-                    <a:solidFill>
-                      <a:srgbClr val="FFFFFF"/>
-                    </a:solidFill>
-                  </a:tcPr>
-                </a:tc>
-                <a:tc>
-                  <a:txBody>
-                    <a:bodyPr/>
-                    <a:lstStyle/>
-                    <a:p>
-                      <a:pPr>
-                        <a:defRPr sz="1300">
-                          <a:solidFill>
-                            <a:srgbClr val="2E3846"/>
-                          </a:solidFill>
-                          <a:latin typeface="Aptos"/>
-                        </a:defRPr>
-                      </a:pPr>
-                      <a:r>
-                        <a:t>Gate controller</a:t>
-                      </a:r>
-                    </a:p>
-                  </a:txBody>
-                  <a:tcPr>
-                    <a:solidFill>
-                      <a:srgbClr val="FFFFFF"/>
-                    </a:solidFill>
-                  </a:tcPr>
-                </a:tc>
-                <a:tc>
-                  <a:txBody>
-                    <a:bodyPr/>
-                    <a:lstStyle/>
-                    <a:p>
-                      <a:pPr>
-                        <a:defRPr sz="1300">
-                          <a:solidFill>
-                            <a:srgbClr val="2E3846"/>
-                          </a:solidFill>
-                          <a:latin typeface="Aptos"/>
-                        </a:defRPr>
-                      </a:pPr>
-                      <a:r>
-                        <a:t>Returns the final decision such as open or wait.</a:t>
-                      </a:r>
-                    </a:p>
-                  </a:txBody>
-                  <a:tcPr>
-                    <a:solidFill>
-                      <a:srgbClr val="FFFFFF"/>
-                    </a:solidFill>
-                  </a:tcPr>
-                </a:tc>
-              </a:tr>
-            </a:tbl>
-          </a:graphicData>
-        </a:graphic>
-      </p:graphicFrame>
-      <p:sp>
-        <p:nvSpPr>
-          <p:cNvPr id="5" name="Rounded Rectangle 4"/>
+              </a:defRPr>
+            </a:pPr>
+            <a:r>
+              <a:t>The project can run as a multi-process MQTT demo.</a:t>
+            </a:r>
+          </a:p>
+          <a:p>
+            <a:pPr>
+              <a:spcAft>
+                <a:spcPts val="400"/>
+              </a:spcAft>
+              <a:defRPr sz="1400">
+                <a:solidFill>
+                  <a:srgbClr val="3D4858"/>
+                </a:solidFill>
+                <a:latin typeface="Aptos"/>
+              </a:defRPr>
+            </a:pPr>
+            <a:r>
+              <a:t>The dashboard, statistics service, and gate logic are already producing visible output.</a:t>
+            </a:r>
+          </a:p>
+          <a:p>
+            <a:pPr>
+              <a:spcAft>
+                <a:spcPts val="400"/>
+              </a:spcAft>
+              <a:defRPr sz="1400">
+                <a:solidFill>
+                  <a:srgbClr val="3D4858"/>
+                </a:solidFill>
+                <a:latin typeface="Aptos"/>
+              </a:defRPr>
+            </a:pPr>
+            <a:r>
+              <a:t>The repository contains code updates, documentation, and presentation material.</a:t>
+            </a:r>
+          </a:p>
+          <a:p>
+            <a:pPr>
+              <a:spcAft>
+                <a:spcPts val="400"/>
+              </a:spcAft>
+              <a:defRPr sz="1400">
+                <a:solidFill>
+                  <a:srgbClr val="3D4858"/>
+                </a:solidFill>
+                <a:latin typeface="Aptos"/>
+              </a:defRPr>
+            </a:pPr>
+            <a:r>
+              <a:t>The current progress is strong enough to demonstrate a working prototype in class.</a:t>
+            </a:r>
+          </a:p>
+        </p:txBody>
+      </p:sp>
+      <p:sp>
+        <p:nvSpPr>
+          <p:cNvPr id="6" name="Rounded Rectangle 5"/>
           <p:cNvSpPr/>
           <p:nvPr/>
         </p:nvSpPr>
         <p:spPr>
           <a:xfrm>
-            <a:off x="868680" y="5212080"/>
-            <a:ext cx="10469880" cy="914400"/>
+            <a:off x="6217920" y="1691640"/>
+            <a:ext cx="5212080" cy="4389120"/>
           </a:xfrm>
           <a:prstGeom prst="roundRect">
             <a:avLst/>
           </a:prstGeom>
           <a:solidFill>
-            <a:srgbClr val="E4ECF7"/>
+            <a:srgbClr val="FFFFFF"/>
           </a:solidFill>
           <a:ln>
-            <a:noFill/>
+            <a:solidFill>
+              <a:srgbClr val="E4ECF7"/>
+            </a:solidFill>
           </a:ln>
         </p:spPr>
         <p:style>
@@ -5132,14 +4967,14 @@
       </p:sp>
       <p:sp>
         <p:nvSpPr>
-          <p:cNvPr id="6" name="TextBox 5"/>
+          <p:cNvPr id="7" name="TextBox 6"/>
           <p:cNvSpPr txBox="1"/>
           <p:nvPr/>
         </p:nvSpPr>
         <p:spPr>
           <a:xfrm>
-            <a:off x="1033271" y="5321808"/>
-            <a:ext cx="10140696" cy="694944"/>
+            <a:off x="6382512" y="1801368"/>
+            <a:ext cx="4882896" cy="4169663"/>
           </a:xfrm>
           <a:prstGeom prst="rect">
             <a:avLst/>
@@ -5147,219 +4982,21 @@
           <a:noFill/>
         </p:spPr>
         <p:txBody>
-          <a:bodyPr wrap="square" anchor="t">
+          <a:bodyPr wrap="none">
             <a:spAutoFit/>
           </a:bodyPr>
           <a:lstStyle/>
           <a:p>
             <a:pPr>
-              <a:spcAft>
-                <a:spcPts val="600"/>
-              </a:spcAft>
-              <a:defRPr sz="1400" b="0">
-                <a:solidFill>
-                  <a:srgbClr val="192C4C"/>
+              <a:defRPr sz="1800" b="1">
+                <a:solidFill>
+                  <a:srgbClr val="182C4C"/>
                 </a:solidFill>
                 <a:latin typeface="Aptos"/>
               </a:defRPr>
             </a:pPr>
             <a:r>
-              <a:t>The overall data flow is straightforward. Sensor messages are published first, then the statistics service aggregates them and produces a summary. When a vehicle request arrives, the gate controller checks the latest summary and sends an entry decision. Because all modules communicate through the broker, the system remains loosely coupled and more flexible than a direct device-to-device design.</a:t>
-            </a:r>
-          </a:p>
-        </p:txBody>
-      </p:sp>
-    </p:spTree>
-  </p:cSld>
-  <p:clrMapOvr>
-    <a:masterClrMapping/>
-  </p:clrMapOvr>
-</p:sld>
-</file>
-
-<file path=ppt/slides/slide5.xml><?xml version="1.0" encoding="utf-8"?>
-<p:sld xmlns:a="http://schemas.openxmlformats.org/drawingml/2006/main" xmlns:p="http://schemas.openxmlformats.org/presentationml/2006/main" xmlns:r="http://schemas.openxmlformats.org/officeDocument/2006/relationships">
-  <p:cSld>
-    <p:bg>
-      <p:bgPr>
-        <a:solidFill>
-          <a:srgbClr val="F7F9FC"/>
-        </a:solidFill>
-        <a:effectLst/>
-      </p:bgPr>
-    </p:bg>
-    <p:spTree>
-      <p:nvGrpSpPr>
-        <p:cNvPr id="1" name=""/>
-        <p:cNvGrpSpPr/>
-        <p:nvPr/>
-      </p:nvGrpSpPr>
-      <p:grpSpPr/>
-      <p:sp>
-        <p:nvSpPr>
-          <p:cNvPr id="2" name="Rectangle 1"/>
-          <p:cNvSpPr/>
-          <p:nvPr/>
-        </p:nvSpPr>
-        <p:spPr>
-          <a:xfrm>
-            <a:off x="0" y="0"/>
-            <a:ext cx="12191695" cy="411480"/>
-          </a:xfrm>
-          <a:prstGeom prst="rect">
-            <a:avLst/>
-          </a:prstGeom>
-          <a:solidFill>
-            <a:srgbClr val="192C4C"/>
-          </a:solidFill>
-          <a:ln>
-            <a:noFill/>
-          </a:ln>
-        </p:spPr>
-        <p:style>
-          <a:lnRef idx="1">
-            <a:schemeClr val="accent1"/>
-          </a:lnRef>
-          <a:fillRef idx="3">
-            <a:schemeClr val="accent1"/>
-          </a:fillRef>
-          <a:effectRef idx="2">
-            <a:schemeClr val="accent1"/>
-          </a:effectRef>
-          <a:fontRef idx="minor">
-            <a:schemeClr val="lt1"/>
-          </a:fontRef>
-        </p:style>
-        <p:txBody>
-          <a:bodyPr rtlCol="0" anchor="ctr"/>
-          <a:lstStyle/>
-          <a:p>
-            <a:pPr algn="ctr"/>
-          </a:p>
-        </p:txBody>
-      </p:sp>
-      <p:sp>
-        <p:nvSpPr>
-          <p:cNvPr id="3" name="TextBox 2"/>
-          <p:cNvSpPr txBox="1"/>
-          <p:nvPr/>
-        </p:nvSpPr>
-        <p:spPr>
-          <a:xfrm>
-            <a:off x="640080" y="658368"/>
-            <a:ext cx="10972800" cy="822960"/>
-          </a:xfrm>
-          <a:prstGeom prst="rect">
-            <a:avLst/>
-          </a:prstGeom>
-          <a:noFill/>
-        </p:spPr>
-        <p:txBody>
-          <a:bodyPr wrap="square">
-            <a:spAutoFit/>
-          </a:bodyPr>
-          <a:lstStyle/>
-          <a:p>
-            <a:r>
-              <a:rPr sz="2600" b="1">
-                <a:solidFill>
-                  <a:srgbClr val="192C4C"/>
-                </a:solidFill>
-                <a:latin typeface="Aptos"/>
-              </a:rPr>
-              <a:t>4. Implementation Details</a:t>
-            </a:r>
-          </a:p>
-          <a:p>
-            <a:r>
-              <a:rPr sz="1300">
-                <a:solidFill>
-                  <a:srgbClr val="2E3846"/>
-                </a:solidFill>
-                <a:latin typeface="Aptos"/>
-              </a:rPr>
-              <a:t>The codebase is small, but each Python module has a distinct role in the prototype.</a:t>
-            </a:r>
-          </a:p>
-        </p:txBody>
-      </p:sp>
-      <p:sp>
-        <p:nvSpPr>
-          <p:cNvPr id="4" name="Rounded Rectangle 3"/>
-          <p:cNvSpPr/>
-          <p:nvPr/>
-        </p:nvSpPr>
-        <p:spPr>
-          <a:xfrm>
-            <a:off x="777240" y="1645920"/>
-            <a:ext cx="3657600" cy="4480560"/>
-          </a:xfrm>
-          <a:prstGeom prst="roundRect">
-            <a:avLst/>
-          </a:prstGeom>
-          <a:solidFill>
-            <a:srgbClr val="FFFFFF"/>
-          </a:solidFill>
-          <a:ln>
-            <a:solidFill>
-              <a:srgbClr val="E4ECF7"/>
-            </a:solidFill>
-          </a:ln>
-        </p:spPr>
-        <p:style>
-          <a:lnRef idx="1">
-            <a:schemeClr val="accent1"/>
-          </a:lnRef>
-          <a:fillRef idx="3">
-            <a:schemeClr val="accent1"/>
-          </a:fillRef>
-          <a:effectRef idx="2">
-            <a:schemeClr val="accent1"/>
-          </a:effectRef>
-          <a:fontRef idx="minor">
-            <a:schemeClr val="lt1"/>
-          </a:fontRef>
-        </p:style>
-        <p:txBody>
-          <a:bodyPr rtlCol="0" anchor="ctr"/>
-          <a:lstStyle/>
-          <a:p>
-            <a:pPr algn="ctr"/>
-          </a:p>
-        </p:txBody>
-      </p:sp>
-      <p:sp>
-        <p:nvSpPr>
-          <p:cNvPr id="5" name="TextBox 4"/>
-          <p:cNvSpPr txBox="1"/>
-          <p:nvPr/>
-        </p:nvSpPr>
-        <p:spPr>
-          <a:xfrm>
-            <a:off x="941832" y="1755648"/>
-            <a:ext cx="3328416" cy="4261104"/>
-          </a:xfrm>
-          <a:prstGeom prst="rect">
-            <a:avLst/>
-          </a:prstGeom>
-          <a:noFill/>
-        </p:spPr>
-        <p:txBody>
-          <a:bodyPr wrap="square">
-            <a:spAutoFit/>
-          </a:bodyPr>
-          <a:lstStyle/>
-          <a:p>
-            <a:pPr>
-              <a:defRPr sz="1900" b="1">
-                <a:solidFill>
-                  <a:srgbClr val="192C4C"/>
-                </a:solidFill>
-                <a:latin typeface="Aptos"/>
-              </a:defRPr>
-            </a:pPr>
-            <a:r>
-              <a:t>Publishers</a:t>
+              <a:t>Reasonable next step</a:t>
             </a:r>
           </a:p>
           <a:p>
@@ -5367,15 +5004,15 @@
               <a:spcAft>
                 <a:spcPts val="400"/>
               </a:spcAft>
-              <a:defRPr sz="1500">
-                <a:solidFill>
-                  <a:srgbClr val="2E3846"/>
+              <a:defRPr sz="1400">
+                <a:solidFill>
+                  <a:srgbClr val="3D4858"/>
                 </a:solidFill>
                 <a:latin typeface="Aptos"/>
               </a:defRPr>
             </a:pPr>
             <a:r>
-              <a:t>publisher_sensor.py simulates five parking slots and publishes free or occupied states at random time intervals.</a:t>
+              <a:t>Improve the visual interface by replacing terminal output with a simple web dashboard.</a:t>
             </a:r>
           </a:p>
           <a:p>
@@ -5383,15 +5020,15 @@
               <a:spcAft>
                 <a:spcPts val="400"/>
               </a:spcAft>
-              <a:defRPr sz="1500">
-                <a:solidFill>
-                  <a:srgbClr val="2E3846"/>
+              <a:defRPr sz="1400">
+                <a:solidFill>
+                  <a:srgbClr val="3D4858"/>
                 </a:solidFill>
                 <a:latin typeface="Aptos"/>
               </a:defRPr>
             </a:pPr>
             <a:r>
-              <a:t>publisher_vehicle_request.py simulates a car arriving at the entrance and publishes a structured request in JSON format.</a:t>
+              <a:t>Store parking events in a database so the team can analyze historical behavior later.</a:t>
             </a:r>
           </a:p>
           <a:p>
@@ -5399,96 +5036,15 @@
               <a:spcAft>
                 <a:spcPts val="400"/>
               </a:spcAft>
-              <a:defRPr sz="1500">
-                <a:solidFill>
-                  <a:srgbClr val="2E3846"/>
+              <a:defRPr sz="1400">
+                <a:solidFill>
+                  <a:srgbClr val="3D4858"/>
                 </a:solidFill>
                 <a:latin typeface="Aptos"/>
               </a:defRPr>
             </a:pPr>
             <a:r>
-              <a:t>Both publishers use the same public broker and send messages continuously to represent a live IoT environment.</a:t>
-            </a:r>
-          </a:p>
-        </p:txBody>
-      </p:sp>
-      <p:sp>
-        <p:nvSpPr>
-          <p:cNvPr id="6" name="Rounded Rectangle 5"/>
-          <p:cNvSpPr/>
-          <p:nvPr/>
-        </p:nvSpPr>
-        <p:spPr>
-          <a:xfrm>
-            <a:off x="4526280" y="1645920"/>
-            <a:ext cx="3657600" cy="4480560"/>
-          </a:xfrm>
-          <a:prstGeom prst="roundRect">
-            <a:avLst/>
-          </a:prstGeom>
-          <a:solidFill>
-            <a:srgbClr val="FFFFFF"/>
-          </a:solidFill>
-          <a:ln>
-            <a:solidFill>
-              <a:srgbClr val="E4ECF7"/>
-            </a:solidFill>
-          </a:ln>
-        </p:spPr>
-        <p:style>
-          <a:lnRef idx="1">
-            <a:schemeClr val="accent1"/>
-          </a:lnRef>
-          <a:fillRef idx="3">
-            <a:schemeClr val="accent1"/>
-          </a:fillRef>
-          <a:effectRef idx="2">
-            <a:schemeClr val="accent1"/>
-          </a:effectRef>
-          <a:fontRef idx="minor">
-            <a:schemeClr val="lt1"/>
-          </a:fontRef>
-        </p:style>
-        <p:txBody>
-          <a:bodyPr rtlCol="0" anchor="ctr"/>
-          <a:lstStyle/>
-          <a:p>
-            <a:pPr algn="ctr"/>
-          </a:p>
-        </p:txBody>
-      </p:sp>
-      <p:sp>
-        <p:nvSpPr>
-          <p:cNvPr id="7" name="TextBox 6"/>
-          <p:cNvSpPr txBox="1"/>
-          <p:nvPr/>
-        </p:nvSpPr>
-        <p:spPr>
-          <a:xfrm>
-            <a:off x="4690872" y="1755648"/>
-            <a:ext cx="3328416" cy="4261104"/>
-          </a:xfrm>
-          <a:prstGeom prst="rect">
-            <a:avLst/>
-          </a:prstGeom>
-          <a:noFill/>
-        </p:spPr>
-        <p:txBody>
-          <a:bodyPr wrap="square">
-            <a:spAutoFit/>
-          </a:bodyPr>
-          <a:lstStyle/>
-          <a:p>
-            <a:pPr>
-              <a:defRPr sz="1900" b="1">
-                <a:solidFill>
-                  <a:srgbClr val="192C4C"/>
-                </a:solidFill>
-                <a:latin typeface="Aptos"/>
-              </a:defRPr>
-            </a:pPr>
-            <a:r>
-              <a:t>Subscribers</a:t>
+              <a:t>Connect the logic to real sensors or a more realistic hardware simulation.</a:t>
             </a:r>
           </a:p>
           <a:p>
@@ -5496,1320 +5052,15 @@
               <a:spcAft>
                 <a:spcPts val="400"/>
               </a:spcAft>
-              <a:defRPr sz="1500">
-                <a:solidFill>
-                  <a:srgbClr val="2E3846"/>
+              <a:defRPr sz="1400">
+                <a:solidFill>
+                  <a:srgbClr val="3D4858"/>
                 </a:solidFill>
                 <a:latin typeface="Aptos"/>
               </a:defRPr>
             </a:pPr>
             <a:r>
-              <a:t>subscriber_display.py receives updates from all parking slots and prints a real-time text dashboard.</a:t>
-            </a:r>
-          </a:p>
-          <a:p>
-            <a:pPr>
-              <a:spcAft>
-                <a:spcPts val="400"/>
-              </a:spcAft>
-              <a:defRPr sz="1500">
-                <a:solidFill>
-                  <a:srgbClr val="2E3846"/>
-                </a:solidFill>
-                <a:latin typeface="Aptos"/>
-              </a:defRPr>
-            </a:pPr>
-            <a:r>
-              <a:t>subscriber_stats.py stores the latest state of each slot and publishes a summary containing free, occupied, and unknown counts.</a:t>
-            </a:r>
-          </a:p>
-          <a:p>
-            <a:pPr>
-              <a:spcAft>
-                <a:spcPts val="400"/>
-              </a:spcAft>
-              <a:defRPr sz="1500">
-                <a:solidFill>
-                  <a:srgbClr val="2E3846"/>
-                </a:solidFill>
-                <a:latin typeface="Aptos"/>
-              </a:defRPr>
-            </a:pPr>
-            <a:r>
-              <a:t>subscriber_gateway.py listens to the summary and the vehicle request topic, then decides whether to open the gate or keep it closed.</a:t>
-            </a:r>
-          </a:p>
-        </p:txBody>
-      </p:sp>
-      <p:sp>
-        <p:nvSpPr>
-          <p:cNvPr id="8" name="Rounded Rectangle 7"/>
-          <p:cNvSpPr/>
-          <p:nvPr/>
-        </p:nvSpPr>
-        <p:spPr>
-          <a:xfrm>
-            <a:off x="8275320" y="1645920"/>
-            <a:ext cx="3154680" cy="4480560"/>
-          </a:xfrm>
-          <a:prstGeom prst="roundRect">
-            <a:avLst/>
-          </a:prstGeom>
-          <a:solidFill>
-            <a:srgbClr val="FFFFFF"/>
-          </a:solidFill>
-          <a:ln>
-            <a:solidFill>
-              <a:srgbClr val="E4ECF7"/>
-            </a:solidFill>
-          </a:ln>
-        </p:spPr>
-        <p:style>
-          <a:lnRef idx="1">
-            <a:schemeClr val="accent1"/>
-          </a:lnRef>
-          <a:fillRef idx="3">
-            <a:schemeClr val="accent1"/>
-          </a:fillRef>
-          <a:effectRef idx="2">
-            <a:schemeClr val="accent1"/>
-          </a:effectRef>
-          <a:fontRef idx="minor">
-            <a:schemeClr val="lt1"/>
-          </a:fontRef>
-        </p:style>
-        <p:txBody>
-          <a:bodyPr rtlCol="0" anchor="ctr"/>
-          <a:lstStyle/>
-          <a:p>
-            <a:pPr algn="ctr"/>
-          </a:p>
-        </p:txBody>
-      </p:sp>
-      <p:sp>
-        <p:nvSpPr>
-          <p:cNvPr id="9" name="TextBox 8"/>
-          <p:cNvSpPr txBox="1"/>
-          <p:nvPr/>
-        </p:nvSpPr>
-        <p:spPr>
-          <a:xfrm>
-            <a:off x="8439912" y="1755648"/>
-            <a:ext cx="2825496" cy="4261104"/>
-          </a:xfrm>
-          <a:prstGeom prst="rect">
-            <a:avLst/>
-          </a:prstGeom>
-          <a:noFill/>
-        </p:spPr>
-        <p:txBody>
-          <a:bodyPr wrap="square">
-            <a:spAutoFit/>
-          </a:bodyPr>
-          <a:lstStyle/>
-          <a:p>
-            <a:pPr>
-              <a:defRPr sz="1900" b="1">
-                <a:solidFill>
-                  <a:srgbClr val="192C4C"/>
-                </a:solidFill>
-                <a:latin typeface="Aptos"/>
-              </a:defRPr>
-            </a:pPr>
-            <a:r>
-              <a:t>Small improvements added</a:t>
-            </a:r>
-          </a:p>
-          <a:p>
-            <a:pPr>
-              <a:spcAft>
-                <a:spcPts val="400"/>
-              </a:spcAft>
-              <a:defRPr sz="1500">
-                <a:solidFill>
-                  <a:srgbClr val="2E3846"/>
-                </a:solidFill>
-                <a:latin typeface="Aptos"/>
-              </a:defRPr>
-            </a:pPr>
-            <a:r>
-              <a:t>A new vehicle request module was added so that the gate logic depends on actual MQTT events.</a:t>
-            </a:r>
-          </a:p>
-          <a:p>
-            <a:pPr>
-              <a:spcAft>
-                <a:spcPts val="400"/>
-              </a:spcAft>
-              <a:defRPr sz="1500">
-                <a:solidFill>
-                  <a:srgbClr val="2E3846"/>
-                </a:solidFill>
-                <a:latin typeface="Aptos"/>
-              </a:defRPr>
-            </a:pPr>
-            <a:r>
-              <a:t>The gate controller was upgraded from a timer-based demo to a decision-based controller.</a:t>
-            </a:r>
-          </a:p>
-          <a:p>
-            <a:pPr>
-              <a:spcAft>
-                <a:spcPts val="400"/>
-              </a:spcAft>
-              <a:defRPr sz="1500">
-                <a:solidFill>
-                  <a:srgbClr val="2E3846"/>
-                </a:solidFill>
-                <a:latin typeface="Aptos"/>
-              </a:defRPr>
-            </a:pPr>
-            <a:r>
-              <a:t>The README and requirements file were rewritten to make the project easier to run and present.</a:t>
-            </a:r>
-          </a:p>
-        </p:txBody>
-      </p:sp>
-    </p:spTree>
-  </p:cSld>
-  <p:clrMapOvr>
-    <a:masterClrMapping/>
-  </p:clrMapOvr>
-</p:sld>
-</file>
-
-<file path=ppt/slides/slide6.xml><?xml version="1.0" encoding="utf-8"?>
-<p:sld xmlns:a="http://schemas.openxmlformats.org/drawingml/2006/main" xmlns:p="http://schemas.openxmlformats.org/presentationml/2006/main" xmlns:r="http://schemas.openxmlformats.org/officeDocument/2006/relationships">
-  <p:cSld>
-    <p:bg>
-      <p:bgPr>
-        <a:solidFill>
-          <a:srgbClr val="F7F9FC"/>
-        </a:solidFill>
-        <a:effectLst/>
-      </p:bgPr>
-    </p:bg>
-    <p:spTree>
-      <p:nvGrpSpPr>
-        <p:cNvPr id="1" name=""/>
-        <p:cNvGrpSpPr/>
-        <p:nvPr/>
-      </p:nvGrpSpPr>
-      <p:grpSpPr/>
-      <p:sp>
-        <p:nvSpPr>
-          <p:cNvPr id="2" name="Rectangle 1"/>
-          <p:cNvSpPr/>
-          <p:nvPr/>
-        </p:nvSpPr>
-        <p:spPr>
-          <a:xfrm>
-            <a:off x="0" y="0"/>
-            <a:ext cx="12191695" cy="411480"/>
-          </a:xfrm>
-          <a:prstGeom prst="rect">
-            <a:avLst/>
-          </a:prstGeom>
-          <a:solidFill>
-            <a:srgbClr val="192C4C"/>
-          </a:solidFill>
-          <a:ln>
-            <a:noFill/>
-          </a:ln>
-        </p:spPr>
-        <p:style>
-          <a:lnRef idx="1">
-            <a:schemeClr val="accent1"/>
-          </a:lnRef>
-          <a:fillRef idx="3">
-            <a:schemeClr val="accent1"/>
-          </a:fillRef>
-          <a:effectRef idx="2">
-            <a:schemeClr val="accent1"/>
-          </a:effectRef>
-          <a:fontRef idx="minor">
-            <a:schemeClr val="lt1"/>
-          </a:fontRef>
-        </p:style>
-        <p:txBody>
-          <a:bodyPr rtlCol="0" anchor="ctr"/>
-          <a:lstStyle/>
-          <a:p>
-            <a:pPr algn="ctr"/>
-          </a:p>
-        </p:txBody>
-      </p:sp>
-      <p:sp>
-        <p:nvSpPr>
-          <p:cNvPr id="3" name="TextBox 2"/>
-          <p:cNvSpPr txBox="1"/>
-          <p:nvPr/>
-        </p:nvSpPr>
-        <p:spPr>
-          <a:xfrm>
-            <a:off x="640080" y="658368"/>
-            <a:ext cx="10972800" cy="822960"/>
-          </a:xfrm>
-          <a:prstGeom prst="rect">
-            <a:avLst/>
-          </a:prstGeom>
-          <a:noFill/>
-        </p:spPr>
-        <p:txBody>
-          <a:bodyPr wrap="square">
-            <a:spAutoFit/>
-          </a:bodyPr>
-          <a:lstStyle/>
-          <a:p>
-            <a:r>
-              <a:rPr sz="2600" b="1">
-                <a:solidFill>
-                  <a:srgbClr val="192C4C"/>
-                </a:solidFill>
-                <a:latin typeface="Aptos"/>
-              </a:rPr>
-              <a:t>5. Testing and Demonstration Results</a:t>
-            </a:r>
-          </a:p>
-          <a:p>
-            <a:r>
-              <a:rPr sz="1300">
-                <a:solidFill>
-                  <a:srgbClr val="2E3846"/>
-                </a:solidFill>
-                <a:latin typeface="Aptos"/>
-              </a:rPr>
-              <a:t>The prototype was tested by running the publishers and subscribers at the same time.</a:t>
-            </a:r>
-          </a:p>
-        </p:txBody>
-      </p:sp>
-      <p:sp>
-        <p:nvSpPr>
-          <p:cNvPr id="4" name="Rounded Rectangle 3"/>
-          <p:cNvSpPr/>
-          <p:nvPr/>
-        </p:nvSpPr>
-        <p:spPr>
-          <a:xfrm>
-            <a:off x="822960" y="1645920"/>
-            <a:ext cx="5029200" cy="1920240"/>
-          </a:xfrm>
-          <a:prstGeom prst="roundRect">
-            <a:avLst/>
-          </a:prstGeom>
-          <a:solidFill>
-            <a:srgbClr val="FFFFFF"/>
-          </a:solidFill>
-          <a:ln>
-            <a:noFill/>
-          </a:ln>
-        </p:spPr>
-        <p:style>
-          <a:lnRef idx="1">
-            <a:schemeClr val="accent1"/>
-          </a:lnRef>
-          <a:fillRef idx="3">
-            <a:schemeClr val="accent1"/>
-          </a:fillRef>
-          <a:effectRef idx="2">
-            <a:schemeClr val="accent1"/>
-          </a:effectRef>
-          <a:fontRef idx="minor">
-            <a:schemeClr val="lt1"/>
-          </a:fontRef>
-        </p:style>
-        <p:txBody>
-          <a:bodyPr rtlCol="0" anchor="ctr"/>
-          <a:lstStyle/>
-          <a:p>
-            <a:pPr algn="ctr"/>
-          </a:p>
-        </p:txBody>
-      </p:sp>
-      <p:sp>
-        <p:nvSpPr>
-          <p:cNvPr id="5" name="TextBox 4"/>
-          <p:cNvSpPr txBox="1"/>
-          <p:nvPr/>
-        </p:nvSpPr>
-        <p:spPr>
-          <a:xfrm>
-            <a:off x="987552" y="1755648"/>
-            <a:ext cx="4700016" cy="1700784"/>
-          </a:xfrm>
-          <a:prstGeom prst="rect">
-            <a:avLst/>
-          </a:prstGeom>
-          <a:noFill/>
-        </p:spPr>
-        <p:txBody>
-          <a:bodyPr wrap="square" anchor="t">
-            <a:spAutoFit/>
-          </a:bodyPr>
-          <a:lstStyle/>
-          <a:p>
-            <a:pPr>
-              <a:spcAft>
-                <a:spcPts val="600"/>
-              </a:spcAft>
-              <a:defRPr sz="1900" b="1">
-                <a:solidFill>
-                  <a:srgbClr val="FFFFFF"/>
-                </a:solidFill>
-                <a:latin typeface="Aptos"/>
-              </a:defRPr>
-            </a:pPr>
-            <a:r>
-              <a:t>Observed behavior</a:t>
-            </a:r>
-          </a:p>
-          <a:p>
-            <a:pPr>
-              <a:spcAft>
-                <a:spcPts val="600"/>
-              </a:spcAft>
-              <a:defRPr sz="1500" b="0">
-                <a:solidFill>
-                  <a:srgbClr val="FFFFFF"/>
-                </a:solidFill>
-                <a:latin typeface="Aptos"/>
-              </a:defRPr>
-            </a:pPr>
-            <a:r>
-              <a:t>During testing, the statistics service successfully received parking slot updates and recalculated the number of free spaces. The gate controller also received those summaries and reacted to vehicle requests in real time. When at least one space was available, the controller published an open decision. If no free space was available at that moment, the controller returned a wait decision instead.</a:t>
-            </a:r>
-          </a:p>
-        </p:txBody>
-      </p:sp>
-      <p:sp>
-        <p:nvSpPr>
-          <p:cNvPr id="6" name="Rounded Rectangle 5"/>
-          <p:cNvSpPr/>
-          <p:nvPr/>
-        </p:nvSpPr>
-        <p:spPr>
-          <a:xfrm>
-            <a:off x="6126480" y="1645920"/>
-            <a:ext cx="5212080" cy="2971800"/>
-          </a:xfrm>
-          <a:prstGeom prst="roundRect">
-            <a:avLst/>
-          </a:prstGeom>
-          <a:solidFill>
-            <a:srgbClr val="192C4C"/>
-          </a:solidFill>
-          <a:ln>
-            <a:noFill/>
-          </a:ln>
-        </p:spPr>
-        <p:style>
-          <a:lnRef idx="1">
-            <a:schemeClr val="accent1"/>
-          </a:lnRef>
-          <a:fillRef idx="3">
-            <a:schemeClr val="accent1"/>
-          </a:fillRef>
-          <a:effectRef idx="2">
-            <a:schemeClr val="accent1"/>
-          </a:effectRef>
-          <a:fontRef idx="minor">
-            <a:schemeClr val="lt1"/>
-          </a:fontRef>
-        </p:style>
-        <p:txBody>
-          <a:bodyPr rtlCol="0" anchor="ctr"/>
-          <a:lstStyle/>
-          <a:p>
-            <a:pPr algn="ctr"/>
-          </a:p>
-        </p:txBody>
-      </p:sp>
-      <p:sp>
-        <p:nvSpPr>
-          <p:cNvPr id="7" name="TextBox 6"/>
-          <p:cNvSpPr txBox="1"/>
-          <p:nvPr/>
-        </p:nvSpPr>
-        <p:spPr>
-          <a:xfrm>
-            <a:off x="6355080" y="1874519"/>
-            <a:ext cx="4754880" cy="2560320"/>
-          </a:xfrm>
-          <a:prstGeom prst="rect">
-            <a:avLst/>
-          </a:prstGeom>
-          <a:noFill/>
-        </p:spPr>
-        <p:txBody>
-          <a:bodyPr wrap="none">
-            <a:spAutoFit/>
-          </a:bodyPr>
-          <a:lstStyle/>
-          <a:p>
-            <a:pPr>
-              <a:spcAft>
-                <a:spcPts val="500"/>
-              </a:spcAft>
-              <a:defRPr sz="1300">
-                <a:solidFill>
-                  <a:srgbClr val="FFFFFF"/>
-                </a:solidFill>
-                <a:latin typeface="Courier New"/>
-              </a:defRPr>
-            </a:pPr>
-            <a:r>
-              <a:t>Gate controller connected and waiting for incoming messages...</a:t>
-            </a:r>
-          </a:p>
-          <a:p>
-            <a:pPr>
-              <a:spcAft>
-                <a:spcPts val="500"/>
-              </a:spcAft>
-              <a:defRPr sz="1300">
-                <a:solidFill>
-                  <a:srgbClr val="FFFFFF"/>
-                </a:solidFill>
-                <a:latin typeface="Courier New"/>
-              </a:defRPr>
-            </a:pPr>
-            <a:r>
-              <a:t>Summary synchronized: current free spaces = 1</a:t>
-            </a:r>
-          </a:p>
-          <a:p>
-            <a:pPr>
-              <a:spcAft>
-                <a:spcPts val="500"/>
-              </a:spcAft>
-              <a:defRPr sz="1300">
-                <a:solidFill>
-                  <a:srgbClr val="FFFFFF"/>
-                </a:solidFill>
-                <a:latin typeface="Courier New"/>
-              </a:defRPr>
-            </a:pPr>
-            <a:r>
-              <a:t>Summary synchronized: current free spaces = 4</a:t>
-            </a:r>
-          </a:p>
-          <a:p>
-            <a:pPr>
-              <a:spcAft>
-                <a:spcPts val="500"/>
-              </a:spcAft>
-              <a:defRPr sz="1300">
-                <a:solidFill>
-                  <a:srgbClr val="FFFFFF"/>
-                </a:solidFill>
-                <a:latin typeface="Courier New"/>
-              </a:defRPr>
-            </a:pPr>
-            <a:r>
-              <a:t>Gate opened: CAR-101 is allowed to enter</a:t>
-            </a:r>
-          </a:p>
-          <a:p>
-            <a:pPr>
-              <a:spcAft>
-                <a:spcPts val="500"/>
-              </a:spcAft>
-              <a:defRPr sz="1300">
-                <a:solidFill>
-                  <a:srgbClr val="FFFFFF"/>
-                </a:solidFill>
-                <a:latin typeface="Courier New"/>
-              </a:defRPr>
-            </a:pPr>
-            <a:r>
-              <a:t>Vehicle request sent: {'vehicle_id': 'CAR-101', 'request_time': '2026-03-26 02:48:08'}</a:t>
-            </a:r>
-          </a:p>
-        </p:txBody>
-      </p:sp>
-      <p:sp>
-        <p:nvSpPr>
-          <p:cNvPr id="8" name="Rounded Rectangle 7"/>
-          <p:cNvSpPr/>
-          <p:nvPr/>
-        </p:nvSpPr>
-        <p:spPr>
-          <a:xfrm>
-            <a:off x="822960" y="4892040"/>
-            <a:ext cx="10515600" cy="914400"/>
-          </a:xfrm>
-          <a:prstGeom prst="roundRect">
-            <a:avLst/>
-          </a:prstGeom>
-          <a:solidFill>
-            <a:srgbClr val="E4ECF7"/>
-          </a:solidFill>
-          <a:ln>
-            <a:noFill/>
-          </a:ln>
-        </p:spPr>
-        <p:style>
-          <a:lnRef idx="1">
-            <a:schemeClr val="accent1"/>
-          </a:lnRef>
-          <a:fillRef idx="3">
-            <a:schemeClr val="accent1"/>
-          </a:fillRef>
-          <a:effectRef idx="2">
-            <a:schemeClr val="accent1"/>
-          </a:effectRef>
-          <a:fontRef idx="minor">
-            <a:schemeClr val="lt1"/>
-          </a:fontRef>
-        </p:style>
-        <p:txBody>
-          <a:bodyPr rtlCol="0" anchor="ctr"/>
-          <a:lstStyle/>
-          <a:p>
-            <a:pPr algn="ctr"/>
-          </a:p>
-        </p:txBody>
-      </p:sp>
-      <p:sp>
-        <p:nvSpPr>
-          <p:cNvPr id="9" name="TextBox 8"/>
-          <p:cNvSpPr txBox="1"/>
-          <p:nvPr/>
-        </p:nvSpPr>
-        <p:spPr>
-          <a:xfrm>
-            <a:off x="987552" y="5001768"/>
-            <a:ext cx="10186416" cy="694944"/>
-          </a:xfrm>
-          <a:prstGeom prst="rect">
-            <a:avLst/>
-          </a:prstGeom>
-          <a:noFill/>
-        </p:spPr>
-        <p:txBody>
-          <a:bodyPr wrap="square" anchor="t">
-            <a:spAutoFit/>
-          </a:bodyPr>
-          <a:lstStyle/>
-          <a:p>
-            <a:pPr>
-              <a:spcAft>
-                <a:spcPts val="600"/>
-              </a:spcAft>
-              <a:defRPr sz="1400" b="0">
-                <a:solidFill>
-                  <a:srgbClr val="192C4C"/>
-                </a:solidFill>
-                <a:latin typeface="Aptos"/>
-              </a:defRPr>
-            </a:pPr>
-            <a:r>
-              <a:t>These results confirm that the core MQTT workflow already works as intended. The prototype is simple, but it clearly demonstrates event publishing, topic subscription, shared broker communication, and decision making based on live data.</a:t>
-            </a:r>
-          </a:p>
-        </p:txBody>
-      </p:sp>
-    </p:spTree>
-  </p:cSld>
-  <p:clrMapOvr>
-    <a:masterClrMapping/>
-  </p:clrMapOvr>
-</p:sld>
-</file>
-
-<file path=ppt/slides/slide7.xml><?xml version="1.0" encoding="utf-8"?>
-<p:sld xmlns:a="http://schemas.openxmlformats.org/drawingml/2006/main" xmlns:p="http://schemas.openxmlformats.org/presentationml/2006/main" xmlns:r="http://schemas.openxmlformats.org/officeDocument/2006/relationships">
-  <p:cSld>
-    <p:bg>
-      <p:bgPr>
-        <a:solidFill>
-          <a:srgbClr val="F7F9FC"/>
-        </a:solidFill>
-        <a:effectLst/>
-      </p:bgPr>
-    </p:bg>
-    <p:spTree>
-      <p:nvGrpSpPr>
-        <p:cNvPr id="1" name=""/>
-        <p:cNvGrpSpPr/>
-        <p:nvPr/>
-      </p:nvGrpSpPr>
-      <p:grpSpPr/>
-      <p:sp>
-        <p:nvSpPr>
-          <p:cNvPr id="2" name="Rectangle 1"/>
-          <p:cNvSpPr/>
-          <p:nvPr/>
-        </p:nvSpPr>
-        <p:spPr>
-          <a:xfrm>
-            <a:off x="0" y="0"/>
-            <a:ext cx="12191695" cy="411480"/>
-          </a:xfrm>
-          <a:prstGeom prst="rect">
-            <a:avLst/>
-          </a:prstGeom>
-          <a:solidFill>
-            <a:srgbClr val="192C4C"/>
-          </a:solidFill>
-          <a:ln>
-            <a:noFill/>
-          </a:ln>
-        </p:spPr>
-        <p:style>
-          <a:lnRef idx="1">
-            <a:schemeClr val="accent1"/>
-          </a:lnRef>
-          <a:fillRef idx="3">
-            <a:schemeClr val="accent1"/>
-          </a:fillRef>
-          <a:effectRef idx="2">
-            <a:schemeClr val="accent1"/>
-          </a:effectRef>
-          <a:fontRef idx="minor">
-            <a:schemeClr val="lt1"/>
-          </a:fontRef>
-        </p:style>
-        <p:txBody>
-          <a:bodyPr rtlCol="0" anchor="ctr"/>
-          <a:lstStyle/>
-          <a:p>
-            <a:pPr algn="ctr"/>
-          </a:p>
-        </p:txBody>
-      </p:sp>
-      <p:sp>
-        <p:nvSpPr>
-          <p:cNvPr id="3" name="TextBox 2"/>
-          <p:cNvSpPr txBox="1"/>
-          <p:nvPr/>
-        </p:nvSpPr>
-        <p:spPr>
-          <a:xfrm>
-            <a:off x="640080" y="658368"/>
-            <a:ext cx="10972800" cy="822960"/>
-          </a:xfrm>
-          <a:prstGeom prst="rect">
-            <a:avLst/>
-          </a:prstGeom>
-          <a:noFill/>
-        </p:spPr>
-        <p:txBody>
-          <a:bodyPr wrap="square">
-            <a:spAutoFit/>
-          </a:bodyPr>
-          <a:lstStyle/>
-          <a:p>
-            <a:r>
-              <a:rPr sz="2600" b="1">
-                <a:solidFill>
-                  <a:srgbClr val="192C4C"/>
-                </a:solidFill>
-                <a:latin typeface="Aptos"/>
-              </a:rPr>
-              <a:t>6. Limitations and Future Improvements</a:t>
-            </a:r>
-          </a:p>
-          <a:p>
-            <a:r>
-              <a:rPr sz="1300">
-                <a:solidFill>
-                  <a:srgbClr val="2E3846"/>
-                </a:solidFill>
-                <a:latin typeface="Aptos"/>
-              </a:rPr>
-              <a:t>This version is a coursework prototype, so several features can still be expanded later.</a:t>
-            </a:r>
-          </a:p>
-        </p:txBody>
-      </p:sp>
-      <p:sp>
-        <p:nvSpPr>
-          <p:cNvPr id="4" name="Rounded Rectangle 3"/>
-          <p:cNvSpPr/>
-          <p:nvPr/>
-        </p:nvSpPr>
-        <p:spPr>
-          <a:xfrm>
-            <a:off x="777240" y="1645920"/>
-            <a:ext cx="5212080" cy="4480560"/>
-          </a:xfrm>
-          <a:prstGeom prst="roundRect">
-            <a:avLst/>
-          </a:prstGeom>
-          <a:solidFill>
-            <a:srgbClr val="FFFFFF"/>
-          </a:solidFill>
-          <a:ln>
-            <a:solidFill>
-              <a:srgbClr val="E4ECF7"/>
-            </a:solidFill>
-          </a:ln>
-        </p:spPr>
-        <p:style>
-          <a:lnRef idx="1">
-            <a:schemeClr val="accent1"/>
-          </a:lnRef>
-          <a:fillRef idx="3">
-            <a:schemeClr val="accent1"/>
-          </a:fillRef>
-          <a:effectRef idx="2">
-            <a:schemeClr val="accent1"/>
-          </a:effectRef>
-          <a:fontRef idx="minor">
-            <a:schemeClr val="lt1"/>
-          </a:fontRef>
-        </p:style>
-        <p:txBody>
-          <a:bodyPr rtlCol="0" anchor="ctr"/>
-          <a:lstStyle/>
-          <a:p>
-            <a:pPr algn="ctr"/>
-          </a:p>
-        </p:txBody>
-      </p:sp>
-      <p:sp>
-        <p:nvSpPr>
-          <p:cNvPr id="5" name="TextBox 4"/>
-          <p:cNvSpPr txBox="1"/>
-          <p:nvPr/>
-        </p:nvSpPr>
-        <p:spPr>
-          <a:xfrm>
-            <a:off x="941832" y="1755648"/>
-            <a:ext cx="4882896" cy="4261104"/>
-          </a:xfrm>
-          <a:prstGeom prst="rect">
-            <a:avLst/>
-          </a:prstGeom>
-          <a:noFill/>
-        </p:spPr>
-        <p:txBody>
-          <a:bodyPr wrap="square">
-            <a:spAutoFit/>
-          </a:bodyPr>
-          <a:lstStyle/>
-          <a:p>
-            <a:pPr>
-              <a:defRPr sz="1900" b="1">
-                <a:solidFill>
-                  <a:srgbClr val="192C4C"/>
-                </a:solidFill>
-                <a:latin typeface="Aptos"/>
-              </a:defRPr>
-            </a:pPr>
-            <a:r>
-              <a:t>Current limitations</a:t>
-            </a:r>
-          </a:p>
-          <a:p>
-            <a:pPr>
-              <a:spcAft>
-                <a:spcPts val="400"/>
-              </a:spcAft>
-              <a:defRPr sz="1500">
-                <a:solidFill>
-                  <a:srgbClr val="2E3846"/>
-                </a:solidFill>
-                <a:latin typeface="Aptos"/>
-              </a:defRPr>
-            </a:pPr>
-            <a:r>
-              <a:t>The project uses a public MQTT broker instead of a private and secured deployment.</a:t>
-            </a:r>
-          </a:p>
-          <a:p>
-            <a:pPr>
-              <a:spcAft>
-                <a:spcPts val="400"/>
-              </a:spcAft>
-              <a:defRPr sz="1500">
-                <a:solidFill>
-                  <a:srgbClr val="2E3846"/>
-                </a:solidFill>
-                <a:latin typeface="Aptos"/>
-              </a:defRPr>
-            </a:pPr>
-            <a:r>
-              <a:t>Parking data is simulated randomly and is not connected to real hardware sensors.</a:t>
-            </a:r>
-          </a:p>
-          <a:p>
-            <a:pPr>
-              <a:spcAft>
-                <a:spcPts val="400"/>
-              </a:spcAft>
-              <a:defRPr sz="1500">
-                <a:solidFill>
-                  <a:srgbClr val="2E3846"/>
-                </a:solidFill>
-                <a:latin typeface="Aptos"/>
-              </a:defRPr>
-            </a:pPr>
-            <a:r>
-              <a:t>The output is shown in terminal windows rather than in a graphical web dashboard.</a:t>
-            </a:r>
-          </a:p>
-          <a:p>
-            <a:pPr>
-              <a:spcAft>
-                <a:spcPts val="400"/>
-              </a:spcAft>
-              <a:defRPr sz="1500">
-                <a:solidFill>
-                  <a:srgbClr val="2E3846"/>
-                </a:solidFill>
-                <a:latin typeface="Aptos"/>
-              </a:defRPr>
-            </a:pPr>
-            <a:r>
-              <a:t>The current workflow does not store historical data in a database for later analysis.</a:t>
-            </a:r>
-          </a:p>
-        </p:txBody>
-      </p:sp>
-      <p:sp>
-        <p:nvSpPr>
-          <p:cNvPr id="6" name="Rounded Rectangle 5"/>
-          <p:cNvSpPr/>
-          <p:nvPr/>
-        </p:nvSpPr>
-        <p:spPr>
-          <a:xfrm>
-            <a:off x="6217920" y="1645920"/>
-            <a:ext cx="5212080" cy="4480560"/>
-          </a:xfrm>
-          <a:prstGeom prst="roundRect">
-            <a:avLst/>
-          </a:prstGeom>
-          <a:solidFill>
-            <a:srgbClr val="FFFFFF"/>
-          </a:solidFill>
-          <a:ln>
-            <a:solidFill>
-              <a:srgbClr val="E4ECF7"/>
-            </a:solidFill>
-          </a:ln>
-        </p:spPr>
-        <p:style>
-          <a:lnRef idx="1">
-            <a:schemeClr val="accent1"/>
-          </a:lnRef>
-          <a:fillRef idx="3">
-            <a:schemeClr val="accent1"/>
-          </a:fillRef>
-          <a:effectRef idx="2">
-            <a:schemeClr val="accent1"/>
-          </a:effectRef>
-          <a:fontRef idx="minor">
-            <a:schemeClr val="lt1"/>
-          </a:fontRef>
-        </p:style>
-        <p:txBody>
-          <a:bodyPr rtlCol="0" anchor="ctr"/>
-          <a:lstStyle/>
-          <a:p>
-            <a:pPr algn="ctr"/>
-          </a:p>
-        </p:txBody>
-      </p:sp>
-      <p:sp>
-        <p:nvSpPr>
-          <p:cNvPr id="7" name="TextBox 6"/>
-          <p:cNvSpPr txBox="1"/>
-          <p:nvPr/>
-        </p:nvSpPr>
-        <p:spPr>
-          <a:xfrm>
-            <a:off x="6382512" y="1755648"/>
-            <a:ext cx="4882896" cy="4261104"/>
-          </a:xfrm>
-          <a:prstGeom prst="rect">
-            <a:avLst/>
-          </a:prstGeom>
-          <a:noFill/>
-        </p:spPr>
-        <p:txBody>
-          <a:bodyPr wrap="square">
-            <a:spAutoFit/>
-          </a:bodyPr>
-          <a:lstStyle/>
-          <a:p>
-            <a:pPr>
-              <a:defRPr sz="1900" b="1">
-                <a:solidFill>
-                  <a:srgbClr val="192C4C"/>
-                </a:solidFill>
-                <a:latin typeface="Aptos"/>
-              </a:defRPr>
-            </a:pPr>
-            <a:r>
-              <a:t>Possible future work</a:t>
-            </a:r>
-          </a:p>
-          <a:p>
-            <a:pPr>
-              <a:spcAft>
-                <a:spcPts val="400"/>
-              </a:spcAft>
-              <a:defRPr sz="1500">
-                <a:solidFill>
-                  <a:srgbClr val="2E3846"/>
-                </a:solidFill>
-                <a:latin typeface="Aptos"/>
-              </a:defRPr>
-            </a:pPr>
-            <a:r>
-              <a:t>Replace the simulated sensor input with real ultrasonic or infrared sensors.</a:t>
-            </a:r>
-          </a:p>
-          <a:p>
-            <a:pPr>
-              <a:spcAft>
-                <a:spcPts val="400"/>
-              </a:spcAft>
-              <a:defRPr sz="1500">
-                <a:solidFill>
-                  <a:srgbClr val="2E3846"/>
-                </a:solidFill>
-                <a:latin typeface="Aptos"/>
-              </a:defRPr>
-            </a:pPr>
-            <a:r>
-              <a:t>Add a database to record parking events, traffic patterns, and gate decisions.</a:t>
-            </a:r>
-          </a:p>
-          <a:p>
-            <a:pPr>
-              <a:spcAft>
-                <a:spcPts val="400"/>
-              </a:spcAft>
-              <a:defRPr sz="1500">
-                <a:solidFill>
-                  <a:srgbClr val="2E3846"/>
-                </a:solidFill>
-                <a:latin typeface="Aptos"/>
-              </a:defRPr>
-            </a:pPr>
-            <a:r>
-              <a:t>Develop a web or mobile dashboard so that users can check parking availability remotely.</a:t>
-            </a:r>
-          </a:p>
-          <a:p>
-            <a:pPr>
-              <a:spcAft>
-                <a:spcPts val="400"/>
-              </a:spcAft>
-              <a:defRPr sz="1500">
-                <a:solidFill>
-                  <a:srgbClr val="2E3846"/>
-                </a:solidFill>
-                <a:latin typeface="Aptos"/>
-              </a:defRPr>
-            </a:pPr>
-            <a:r>
-              <a:t>Extend the system with reservation, pricing, and license plate recognition features.</a:t>
-            </a:r>
-          </a:p>
-        </p:txBody>
-      </p:sp>
-    </p:spTree>
-  </p:cSld>
-  <p:clrMapOvr>
-    <a:masterClrMapping/>
-  </p:clrMapOvr>
-</p:sld>
-</file>
-
-<file path=ppt/slides/slide8.xml><?xml version="1.0" encoding="utf-8"?>
-<p:sld xmlns:a="http://schemas.openxmlformats.org/drawingml/2006/main" xmlns:p="http://schemas.openxmlformats.org/presentationml/2006/main" xmlns:r="http://schemas.openxmlformats.org/officeDocument/2006/relationships">
-  <p:cSld>
-    <p:bg>
-      <p:bgPr>
-        <a:solidFill>
-          <a:srgbClr val="F7F9FC"/>
-        </a:solidFill>
-        <a:effectLst/>
-      </p:bgPr>
-    </p:bg>
-    <p:spTree>
-      <p:nvGrpSpPr>
-        <p:cNvPr id="1" name=""/>
-        <p:cNvGrpSpPr/>
-        <p:nvPr/>
-      </p:nvGrpSpPr>
-      <p:grpSpPr/>
-      <p:sp>
-        <p:nvSpPr>
-          <p:cNvPr id="2" name="Rectangle 1"/>
-          <p:cNvSpPr/>
-          <p:nvPr/>
-        </p:nvSpPr>
-        <p:spPr>
-          <a:xfrm>
-            <a:off x="0" y="0"/>
-            <a:ext cx="12191695" cy="411480"/>
-          </a:xfrm>
-          <a:prstGeom prst="rect">
-            <a:avLst/>
-          </a:prstGeom>
-          <a:solidFill>
-            <a:srgbClr val="192C4C"/>
-          </a:solidFill>
-          <a:ln>
-            <a:noFill/>
-          </a:ln>
-        </p:spPr>
-        <p:style>
-          <a:lnRef idx="1">
-            <a:schemeClr val="accent1"/>
-          </a:lnRef>
-          <a:fillRef idx="3">
-            <a:schemeClr val="accent1"/>
-          </a:fillRef>
-          <a:effectRef idx="2">
-            <a:schemeClr val="accent1"/>
-          </a:effectRef>
-          <a:fontRef idx="minor">
-            <a:schemeClr val="lt1"/>
-          </a:fontRef>
-        </p:style>
-        <p:txBody>
-          <a:bodyPr rtlCol="0" anchor="ctr"/>
-          <a:lstStyle/>
-          <a:p>
-            <a:pPr algn="ctr"/>
-          </a:p>
-        </p:txBody>
-      </p:sp>
-      <p:sp>
-        <p:nvSpPr>
-          <p:cNvPr id="3" name="TextBox 2"/>
-          <p:cNvSpPr txBox="1"/>
-          <p:nvPr/>
-        </p:nvSpPr>
-        <p:spPr>
-          <a:xfrm>
-            <a:off x="640080" y="658368"/>
-            <a:ext cx="10972800" cy="822960"/>
-          </a:xfrm>
-          <a:prstGeom prst="rect">
-            <a:avLst/>
-          </a:prstGeom>
-          <a:noFill/>
-        </p:spPr>
-        <p:txBody>
-          <a:bodyPr wrap="square">
-            <a:spAutoFit/>
-          </a:bodyPr>
-          <a:lstStyle/>
-          <a:p>
-            <a:r>
-              <a:rPr sz="2600" b="1">
-                <a:solidFill>
-                  <a:srgbClr val="192C4C"/>
-                </a:solidFill>
-                <a:latin typeface="Aptos"/>
-              </a:rPr>
-              <a:t>7. Conclusion</a:t>
-            </a:r>
-          </a:p>
-          <a:p>
-            <a:r>
-              <a:rPr sz="1300">
-                <a:solidFill>
-                  <a:srgbClr val="2E3846"/>
-                </a:solidFill>
-                <a:latin typeface="Aptos"/>
-              </a:rPr>
-              <a:t>The project meets the coursework goal by presenting a working MQTT-based smart parking prototype.</a:t>
-            </a:r>
-          </a:p>
-        </p:txBody>
-      </p:sp>
-      <p:sp>
-        <p:nvSpPr>
-          <p:cNvPr id="4" name="Rounded Rectangle 3"/>
-          <p:cNvSpPr/>
-          <p:nvPr/>
-        </p:nvSpPr>
-        <p:spPr>
-          <a:xfrm>
-            <a:off x="868680" y="1783080"/>
-            <a:ext cx="10332720" cy="1828800"/>
-          </a:xfrm>
-          <a:prstGeom prst="roundRect">
-            <a:avLst/>
-          </a:prstGeom>
-          <a:solidFill>
-            <a:srgbClr val="FFFFFF"/>
-          </a:solidFill>
-          <a:ln>
-            <a:noFill/>
-          </a:ln>
-        </p:spPr>
-        <p:style>
-          <a:lnRef idx="1">
-            <a:schemeClr val="accent1"/>
-          </a:lnRef>
-          <a:fillRef idx="3">
-            <a:schemeClr val="accent1"/>
-          </a:fillRef>
-          <a:effectRef idx="2">
-            <a:schemeClr val="accent1"/>
-          </a:effectRef>
-          <a:fontRef idx="minor">
-            <a:schemeClr val="lt1"/>
-          </a:fontRef>
-        </p:style>
-        <p:txBody>
-          <a:bodyPr rtlCol="0" anchor="ctr"/>
-          <a:lstStyle/>
-          <a:p>
-            <a:pPr algn="ctr"/>
-          </a:p>
-        </p:txBody>
-      </p:sp>
-      <p:sp>
-        <p:nvSpPr>
-          <p:cNvPr id="5" name="TextBox 4"/>
-          <p:cNvSpPr txBox="1"/>
-          <p:nvPr/>
-        </p:nvSpPr>
-        <p:spPr>
-          <a:xfrm>
-            <a:off x="1033271" y="1892807"/>
-            <a:ext cx="10003536" cy="1609344"/>
-          </a:xfrm>
-          <a:prstGeom prst="rect">
-            <a:avLst/>
-          </a:prstGeom>
-          <a:noFill/>
-        </p:spPr>
-        <p:txBody>
-          <a:bodyPr wrap="square" anchor="t">
-            <a:spAutoFit/>
-          </a:bodyPr>
-          <a:lstStyle/>
-          <a:p>
-            <a:pPr>
-              <a:spcAft>
-                <a:spcPts val="600"/>
-              </a:spcAft>
-              <a:defRPr sz="2100" b="1">
-                <a:solidFill>
-                  <a:srgbClr val="FFFFFF"/>
-                </a:solidFill>
-                <a:latin typeface="Aptos"/>
-              </a:defRPr>
-            </a:pPr>
-            <a:r>
-              <a:t>Project summary</a:t>
-            </a:r>
-          </a:p>
-          <a:p>
-            <a:pPr>
-              <a:spcAft>
-                <a:spcPts val="600"/>
-              </a:spcAft>
-              <a:defRPr sz="1600" b="0">
-                <a:solidFill>
-                  <a:srgbClr val="FFFFFF"/>
-                </a:solidFill>
-                <a:latin typeface="Aptos"/>
-              </a:defRPr>
-            </a:pPr>
-            <a:r>
-              <a:t>In conclusion, this prototype shows how MQTT can be applied to a smart parking scenario in a clear and practical way. The project includes message publishers, message subscribers, a shared broker, topic design, statistics processing, and gate decision logic. Although the system is still small, it already demonstrates the essential ideas behind IoT communication and distributed services. This makes it a suitable foundation for further development in later coursework stages.</a:t>
-            </a:r>
-          </a:p>
-        </p:txBody>
-      </p:sp>
-      <p:sp>
-        <p:nvSpPr>
-          <p:cNvPr id="6" name="Rounded Rectangle 5"/>
-          <p:cNvSpPr/>
-          <p:nvPr/>
-        </p:nvSpPr>
-        <p:spPr>
-          <a:xfrm>
-            <a:off x="1645920" y="4251960"/>
-            <a:ext cx="8869680" cy="1188720"/>
-          </a:xfrm>
-          <a:prstGeom prst="roundRect">
-            <a:avLst/>
-          </a:prstGeom>
-          <a:solidFill>
-            <a:srgbClr val="2A8F88"/>
-          </a:solidFill>
-          <a:ln>
-            <a:noFill/>
-          </a:ln>
-        </p:spPr>
-        <p:style>
-          <a:lnRef idx="1">
-            <a:schemeClr val="accent1"/>
-          </a:lnRef>
-          <a:fillRef idx="3">
-            <a:schemeClr val="accent1"/>
-          </a:fillRef>
-          <a:effectRef idx="2">
-            <a:schemeClr val="accent1"/>
-          </a:effectRef>
-          <a:fontRef idx="minor">
-            <a:schemeClr val="lt1"/>
-          </a:fontRef>
-        </p:style>
-        <p:txBody>
-          <a:bodyPr rtlCol="0" anchor="ctr"/>
-          <a:lstStyle/>
-          <a:p>
-            <a:pPr algn="ctr">
-              <a:defRPr sz="2100" b="1">
-                <a:solidFill>
-                  <a:srgbClr val="FFFFFF"/>
-                </a:solidFill>
-                <a:latin typeface="Aptos"/>
-              </a:defRPr>
-            </a:pPr>
-            <a:r>
-              <a:t>Smart Parking with MQTT: a simple prototype, a clear message flow, and a strong base for future extension.</a:t>
-            </a:r>
-          </a:p>
-        </p:txBody>
-      </p:sp>
-      <p:sp>
-        <p:nvSpPr>
-          <p:cNvPr id="7" name="TextBox 6"/>
-          <p:cNvSpPr txBox="1"/>
-          <p:nvPr/>
-        </p:nvSpPr>
-        <p:spPr>
-          <a:xfrm>
-            <a:off x="868680" y="5806440"/>
-            <a:ext cx="10332720" cy="365760"/>
-          </a:xfrm>
-          <a:prstGeom prst="rect">
-            <a:avLst/>
-          </a:prstGeom>
-          <a:noFill/>
-        </p:spPr>
-        <p:txBody>
-          <a:bodyPr wrap="none">
-            <a:spAutoFit/>
-          </a:bodyPr>
-          <a:lstStyle/>
-          <a:p>
-            <a:pPr algn="ctr"/>
-            <a:r>
-              <a:rPr sz="2400" b="1">
-                <a:solidFill>
-                  <a:srgbClr val="192C4C"/>
-                </a:solidFill>
-                <a:latin typeface="Aptos"/>
-              </a:rPr>
-              <a:t>Thank you.</a:t>
+              <a:t>Keep extending the repository with cleaner version control and team collaboration records.</a:t>
             </a:r>
           </a:p>
         </p:txBody>

</xml_diff>

<commit_message>
Add architecture diagram to progress presentation
</commit_message>
<xml_diff>
--- a/presentation/Smart_Parking_MQTT_Presentation_EN.pptx
+++ b/presentation/Smart_Parking_MQTT_Presentation_EN.pptx
@@ -11,6 +11,7 @@
     <p:sldId id="259" r:id="rId10"/>
     <p:sldId id="260" r:id="rId11"/>
     <p:sldId id="261" r:id="rId12"/>
+    <p:sldId id="262" r:id="rId13"/>
   </p:sldIdLst>
   <p:sldSz cx="12191695" cy="6858000" type="screen4x3"/>
   <p:notesSz cx="6858000" cy="9144000"/>
@@ -3894,7 +3895,7 @@
                 </a:solidFill>
                 <a:latin typeface="Aptos"/>
               </a:rPr>
-              <a:t>2. Live Demo: Dashboard Output</a:t>
+              <a:t>2. Current System Architecture</a:t>
             </a:r>
           </a:p>
           <a:p>
@@ -3905,14 +3906,14 @@
                 </a:solidFill>
                 <a:latin typeface="Aptos"/>
               </a:rPr>
-              <a:t>The screenshot below comes from the current run of subscriber_display.py.</a:t>
+              <a:t>This architecture diagram matches the modules that are active in the present demo.</a:t>
             </a:r>
           </a:p>
         </p:txBody>
       </p:sp>
       <p:pic>
         <p:nvPicPr>
-          <p:cNvPr id="4" name="Picture 3" descr="demo_dashboard.png"/>
+          <p:cNvPr id="4" name="Picture 3" descr="architecture_diagram.png"/>
           <p:cNvPicPr>
             <a:picLocks noChangeAspect="1"/>
           </p:cNvPicPr>
@@ -3926,202 +3927,14 @@
         </p:blipFill>
         <p:spPr>
           <a:xfrm>
-            <a:off x="713232" y="1508760"/>
-            <a:ext cx="6583680" cy="4114800"/>
+            <a:off x="621792" y="1417320"/>
+            <a:ext cx="10972800" cy="5257800"/>
           </a:xfrm>
           <a:prstGeom prst="rect">
             <a:avLst/>
           </a:prstGeom>
         </p:spPr>
       </p:pic>
-      <p:sp>
-        <p:nvSpPr>
-          <p:cNvPr id="5" name="Rounded Rectangle 4"/>
-          <p:cNvSpPr/>
-          <p:nvPr/>
-        </p:nvSpPr>
-        <p:spPr>
-          <a:xfrm>
-            <a:off x="7498079" y="1600200"/>
-            <a:ext cx="4069080" cy="3931920"/>
-          </a:xfrm>
-          <a:prstGeom prst="roundRect">
-            <a:avLst/>
-          </a:prstGeom>
-          <a:solidFill>
-            <a:srgbClr val="FFFFFF"/>
-          </a:solidFill>
-          <a:ln>
-            <a:solidFill>
-              <a:srgbClr val="E4ECF7"/>
-            </a:solidFill>
-          </a:ln>
-        </p:spPr>
-        <p:style>
-          <a:lnRef idx="1">
-            <a:schemeClr val="accent1"/>
-          </a:lnRef>
-          <a:fillRef idx="3">
-            <a:schemeClr val="accent1"/>
-          </a:fillRef>
-          <a:effectRef idx="2">
-            <a:schemeClr val="accent1"/>
-          </a:effectRef>
-          <a:fontRef idx="minor">
-            <a:schemeClr val="lt1"/>
-          </a:fontRef>
-        </p:style>
-        <p:txBody>
-          <a:bodyPr rtlCol="0" anchor="ctr"/>
-          <a:lstStyle/>
-          <a:p>
-            <a:pPr algn="ctr"/>
-          </a:p>
-        </p:txBody>
-      </p:sp>
-      <p:sp>
-        <p:nvSpPr>
-          <p:cNvPr id="6" name="TextBox 5"/>
-          <p:cNvSpPr txBox="1"/>
-          <p:nvPr/>
-        </p:nvSpPr>
-        <p:spPr>
-          <a:xfrm>
-            <a:off x="7662671" y="1709928"/>
-            <a:ext cx="3739896" cy="3712463"/>
-          </a:xfrm>
-          <a:prstGeom prst="rect">
-            <a:avLst/>
-          </a:prstGeom>
-          <a:noFill/>
-        </p:spPr>
-        <p:txBody>
-          <a:bodyPr wrap="none">
-            <a:spAutoFit/>
-          </a:bodyPr>
-          <a:lstStyle/>
-          <a:p>
-            <a:pPr>
-              <a:defRPr sz="1800" b="1">
-                <a:solidFill>
-                  <a:srgbClr val="182C4C"/>
-                </a:solidFill>
-                <a:latin typeface="Aptos"/>
-              </a:defRPr>
-            </a:pPr>
-            <a:r>
-              <a:t>What the screenshot shows</a:t>
-            </a:r>
-          </a:p>
-          <a:p>
-            <a:pPr>
-              <a:defRPr sz="1400">
-                <a:solidFill>
-                  <a:srgbClr val="3D4858"/>
-                </a:solidFill>
-                <a:latin typeface="Aptos"/>
-              </a:defRPr>
-            </a:pPr>
-            <a:r>
-              <a:t>The dashboard is already receiving live parking slot messages and updating the visible status table. In this captured state, every slot has been reported, and the system is showing both occupied and free spaces in real time. This demonstrates that the subscription side of the prototype is functioning correctly and that the parking status topic design is usable in practice.</a:t>
-            </a:r>
-          </a:p>
-        </p:txBody>
-      </p:sp>
-      <p:sp>
-        <p:nvSpPr>
-          <p:cNvPr id="7" name="Rounded Rectangle 6"/>
-          <p:cNvSpPr/>
-          <p:nvPr/>
-        </p:nvSpPr>
-        <p:spPr>
-          <a:xfrm>
-            <a:off x="822960" y="5715000"/>
-            <a:ext cx="10744200" cy="658368"/>
-          </a:xfrm>
-          <a:prstGeom prst="roundRect">
-            <a:avLst/>
-          </a:prstGeom>
-          <a:solidFill>
-            <a:srgbClr val="E4ECF7"/>
-          </a:solidFill>
-          <a:ln>
-            <a:solidFill>
-              <a:srgbClr val="E4ECF7"/>
-            </a:solidFill>
-          </a:ln>
-        </p:spPr>
-        <p:style>
-          <a:lnRef idx="1">
-            <a:schemeClr val="accent1"/>
-          </a:lnRef>
-          <a:fillRef idx="3">
-            <a:schemeClr val="accent1"/>
-          </a:fillRef>
-          <a:effectRef idx="2">
-            <a:schemeClr val="accent1"/>
-          </a:effectRef>
-          <a:fontRef idx="minor">
-            <a:schemeClr val="lt1"/>
-          </a:fontRef>
-        </p:style>
-        <p:txBody>
-          <a:bodyPr rtlCol="0" anchor="ctr"/>
-          <a:lstStyle/>
-          <a:p>
-            <a:pPr algn="ctr"/>
-          </a:p>
-        </p:txBody>
-      </p:sp>
-      <p:sp>
-        <p:nvSpPr>
-          <p:cNvPr id="8" name="TextBox 7"/>
-          <p:cNvSpPr txBox="1"/>
-          <p:nvPr/>
-        </p:nvSpPr>
-        <p:spPr>
-          <a:xfrm>
-            <a:off x="987552" y="5824728"/>
-            <a:ext cx="10415016" cy="438912"/>
-          </a:xfrm>
-          <a:prstGeom prst="rect">
-            <a:avLst/>
-          </a:prstGeom>
-          <a:noFill/>
-        </p:spPr>
-        <p:txBody>
-          <a:bodyPr wrap="none">
-            <a:spAutoFit/>
-          </a:bodyPr>
-          <a:lstStyle/>
-          <a:p>
-            <a:pPr>
-              <a:defRPr sz="1800" b="1">
-                <a:solidFill>
-                  <a:srgbClr val="182C4C"/>
-                </a:solidFill>
-                <a:latin typeface="Aptos"/>
-              </a:defRPr>
-            </a:pPr>
-            <a:r>
-              <a:t>Progress value</a:t>
-            </a:r>
-          </a:p>
-          <a:p>
-            <a:pPr>
-              <a:defRPr sz="1400">
-                <a:solidFill>
-                  <a:srgbClr val="3D4858"/>
-                </a:solidFill>
-                <a:latin typeface="Aptos"/>
-              </a:defRPr>
-            </a:pPr>
-            <a:r>
-              <a:t>This output proves that the project already has a working real-time monitoring view, even though it is currently implemented in the terminal instead of a graphical web page.</a:t>
-            </a:r>
-          </a:p>
-        </p:txBody>
-      </p:sp>
     </p:spTree>
   </p:cSld>
   <p:clrMapOvr>
@@ -4220,7 +4033,7 @@
                 </a:solidFill>
                 <a:latin typeface="Aptos"/>
               </a:rPr>
-              <a:t>3. Live Demo: Message Publishing and Service Interaction</a:t>
+              <a:t>3. Live Demo: Dashboard Output</a:t>
             </a:r>
           </a:p>
           <a:p>
@@ -4231,14 +4044,14 @@
                 </a:solidFill>
                 <a:latin typeface="Aptos"/>
               </a:rPr>
-              <a:t>The current prototype already has active publishers and reactive service logic.</a:t>
+              <a:t>The screenshot below comes from the current run of subscriber_display.py.</a:t>
             </a:r>
           </a:p>
         </p:txBody>
       </p:sp>
       <p:pic>
         <p:nvPicPr>
-          <p:cNvPr id="4" name="Picture 3" descr="demo_publishers.png"/>
+          <p:cNvPr id="4" name="Picture 3" descr="demo_dashboard.png"/>
           <p:cNvPicPr>
             <a:picLocks noChangeAspect="1"/>
           </p:cNvPicPr>
@@ -4252,48 +4065,24 @@
         </p:blipFill>
         <p:spPr>
           <a:xfrm>
-            <a:off x="749808" y="1572768"/>
-            <a:ext cx="5532120" cy="3154680"/>
+            <a:off x="713232" y="1508760"/>
+            <a:ext cx="6583680" cy="4114800"/>
           </a:xfrm>
           <a:prstGeom prst="rect">
             <a:avLst/>
           </a:prstGeom>
         </p:spPr>
       </p:pic>
-      <p:pic>
-        <p:nvPicPr>
-          <p:cNvPr id="5" name="Picture 4" descr="demo_services.png"/>
-          <p:cNvPicPr>
-            <a:picLocks noChangeAspect="1"/>
-          </p:cNvPicPr>
-          <p:nvPr/>
-        </p:nvPicPr>
-        <p:blipFill>
-          <a:blip r:embed="rId3"/>
-          <a:stretch>
-            <a:fillRect/>
-          </a:stretch>
-        </p:blipFill>
-        <p:spPr>
-          <a:xfrm>
-            <a:off x="6355080" y="1572768"/>
-            <a:ext cx="5084064" cy="3154680"/>
-          </a:xfrm>
-          <a:prstGeom prst="rect">
-            <a:avLst/>
-          </a:prstGeom>
-        </p:spPr>
-      </p:pic>
-      <p:sp>
-        <p:nvSpPr>
-          <p:cNvPr id="6" name="Rounded Rectangle 5"/>
+      <p:sp>
+        <p:nvSpPr>
+          <p:cNvPr id="5" name="Rounded Rectangle 4"/>
           <p:cNvSpPr/>
           <p:nvPr/>
         </p:nvSpPr>
         <p:spPr>
           <a:xfrm>
-            <a:off x="822960" y="4892040"/>
-            <a:ext cx="10972800" cy="1051560"/>
+            <a:off x="7498079" y="1600200"/>
+            <a:ext cx="4069080" cy="3931920"/>
           </a:xfrm>
           <a:prstGeom prst="roundRect">
             <a:avLst/>
@@ -4331,14 +4120,14 @@
       </p:sp>
       <p:sp>
         <p:nvSpPr>
-          <p:cNvPr id="7" name="TextBox 6"/>
+          <p:cNvPr id="6" name="TextBox 5"/>
           <p:cNvSpPr txBox="1"/>
           <p:nvPr/>
         </p:nvSpPr>
         <p:spPr>
           <a:xfrm>
-            <a:off x="987552" y="5001768"/>
-            <a:ext cx="10643616" cy="832103"/>
+            <a:off x="7662671" y="1709928"/>
+            <a:ext cx="3739896" cy="3712463"/>
           </a:xfrm>
           <a:prstGeom prst="rect">
             <a:avLst/>
@@ -4360,7 +4149,7 @@
               </a:defRPr>
             </a:pPr>
             <a:r>
-              <a:t>Observed result</a:t>
+              <a:t>What the screenshot shows</a:t>
             </a:r>
           </a:p>
           <a:p>
@@ -4373,7 +4162,101 @@
               </a:defRPr>
             </a:pPr>
             <a:r>
-              <a:t>On the left, the publishers are actively sending sensor updates and vehicle entry requests. On the right, the statistics service is continuously recalculating free spaces, and the gate controller is reacting to incoming requests by opening the gate when spaces are available. This means the project already supports a full message loop rather than isolated scripts.</a:t>
+              <a:t>The dashboard is already receiving live parking slot messages and updating the visible status table. In this captured state, every slot has been reported, and the system is showing both occupied and free spaces in real time. This demonstrates that the subscription side of the prototype is functioning correctly and that the parking status topic design is usable in practice.</a:t>
+            </a:r>
+          </a:p>
+        </p:txBody>
+      </p:sp>
+      <p:sp>
+        <p:nvSpPr>
+          <p:cNvPr id="7" name="Rounded Rectangle 6"/>
+          <p:cNvSpPr/>
+          <p:nvPr/>
+        </p:nvSpPr>
+        <p:spPr>
+          <a:xfrm>
+            <a:off x="822960" y="5715000"/>
+            <a:ext cx="10744200" cy="658368"/>
+          </a:xfrm>
+          <a:prstGeom prst="roundRect">
+            <a:avLst/>
+          </a:prstGeom>
+          <a:solidFill>
+            <a:srgbClr val="E4ECF7"/>
+          </a:solidFill>
+          <a:ln>
+            <a:solidFill>
+              <a:srgbClr val="E4ECF7"/>
+            </a:solidFill>
+          </a:ln>
+        </p:spPr>
+        <p:style>
+          <a:lnRef idx="1">
+            <a:schemeClr val="accent1"/>
+          </a:lnRef>
+          <a:fillRef idx="3">
+            <a:schemeClr val="accent1"/>
+          </a:fillRef>
+          <a:effectRef idx="2">
+            <a:schemeClr val="accent1"/>
+          </a:effectRef>
+          <a:fontRef idx="minor">
+            <a:schemeClr val="lt1"/>
+          </a:fontRef>
+        </p:style>
+        <p:txBody>
+          <a:bodyPr rtlCol="0" anchor="ctr"/>
+          <a:lstStyle/>
+          <a:p>
+            <a:pPr algn="ctr"/>
+          </a:p>
+        </p:txBody>
+      </p:sp>
+      <p:sp>
+        <p:nvSpPr>
+          <p:cNvPr id="8" name="TextBox 7"/>
+          <p:cNvSpPr txBox="1"/>
+          <p:nvPr/>
+        </p:nvSpPr>
+        <p:spPr>
+          <a:xfrm>
+            <a:off x="987552" y="5824728"/>
+            <a:ext cx="10415016" cy="438912"/>
+          </a:xfrm>
+          <a:prstGeom prst="rect">
+            <a:avLst/>
+          </a:prstGeom>
+          <a:noFill/>
+        </p:spPr>
+        <p:txBody>
+          <a:bodyPr wrap="none">
+            <a:spAutoFit/>
+          </a:bodyPr>
+          <a:lstStyle/>
+          <a:p>
+            <a:pPr>
+              <a:defRPr sz="1800" b="1">
+                <a:solidFill>
+                  <a:srgbClr val="182C4C"/>
+                </a:solidFill>
+                <a:latin typeface="Aptos"/>
+              </a:defRPr>
+            </a:pPr>
+            <a:r>
+              <a:t>Progress value</a:t>
+            </a:r>
+          </a:p>
+          <a:p>
+            <a:pPr>
+              <a:defRPr sz="1400">
+                <a:solidFill>
+                  <a:srgbClr val="3D4858"/>
+                </a:solidFill>
+                <a:latin typeface="Aptos"/>
+              </a:defRPr>
+            </a:pPr>
+            <a:r>
+              <a:t>This output proves that the project already has a working real-time monitoring view, even though it is currently implemented in the terminal instead of a graphical web page.</a:t>
             </a:r>
           </a:p>
         </p:txBody>
@@ -4476,7 +4359,7 @@
                 </a:solidFill>
                 <a:latin typeface="Aptos"/>
               </a:rPr>
-              <a:t>4. GitHub Progress and Commit Record</a:t>
+              <a:t>4. Live Demo: Message Publishing and Service Interaction</a:t>
             </a:r>
           </a:p>
           <a:p>
@@ -4487,14 +4370,14 @@
                 </a:solidFill>
                 <a:latin typeface="Aptos"/>
               </a:rPr>
-              <a:t>The repository history now reflects the recent implementation and presentation work.</a:t>
+              <a:t>The current prototype already has active publishers and reactive service logic.</a:t>
             </a:r>
           </a:p>
         </p:txBody>
       </p:sp>
       <p:pic>
         <p:nvPicPr>
-          <p:cNvPr id="4" name="Picture 3" descr="github_commits_framed.png"/>
+          <p:cNvPr id="4" name="Picture 3" descr="demo_publishers.png"/>
           <p:cNvPicPr>
             <a:picLocks noChangeAspect="1"/>
           </p:cNvPicPr>
@@ -4508,24 +4391,48 @@
         </p:blipFill>
         <p:spPr>
           <a:xfrm>
-            <a:off x="658368" y="1417320"/>
-            <a:ext cx="7589520" cy="4800600"/>
+            <a:off x="749808" y="1572768"/>
+            <a:ext cx="5532120" cy="3154680"/>
           </a:xfrm>
           <a:prstGeom prst="rect">
             <a:avLst/>
           </a:prstGeom>
         </p:spPr>
       </p:pic>
-      <p:sp>
-        <p:nvSpPr>
-          <p:cNvPr id="5" name="Rounded Rectangle 4"/>
+      <p:pic>
+        <p:nvPicPr>
+          <p:cNvPr id="5" name="Picture 4" descr="demo_services.png"/>
+          <p:cNvPicPr>
+            <a:picLocks noChangeAspect="1"/>
+          </p:cNvPicPr>
+          <p:nvPr/>
+        </p:nvPicPr>
+        <p:blipFill>
+          <a:blip r:embed="rId3"/>
+          <a:stretch>
+            <a:fillRect/>
+          </a:stretch>
+        </p:blipFill>
+        <p:spPr>
+          <a:xfrm>
+            <a:off x="6355080" y="1572768"/>
+            <a:ext cx="5084064" cy="3154680"/>
+          </a:xfrm>
+          <a:prstGeom prst="rect">
+            <a:avLst/>
+          </a:prstGeom>
+        </p:spPr>
+      </p:pic>
+      <p:sp>
+        <p:nvSpPr>
+          <p:cNvPr id="6" name="Rounded Rectangle 5"/>
           <p:cNvSpPr/>
           <p:nvPr/>
         </p:nvSpPr>
         <p:spPr>
           <a:xfrm>
-            <a:off x="8458200" y="1600200"/>
-            <a:ext cx="3063240" cy="4206240"/>
+            <a:off x="822960" y="4892040"/>
+            <a:ext cx="10972800" cy="1051560"/>
           </a:xfrm>
           <a:prstGeom prst="roundRect">
             <a:avLst/>
@@ -4563,14 +4470,14 @@
       </p:sp>
       <p:sp>
         <p:nvSpPr>
-          <p:cNvPr id="6" name="TextBox 5"/>
+          <p:cNvPr id="7" name="TextBox 6"/>
           <p:cNvSpPr txBox="1"/>
           <p:nvPr/>
         </p:nvSpPr>
         <p:spPr>
           <a:xfrm>
-            <a:off x="8622792" y="1709928"/>
-            <a:ext cx="2734056" cy="3986783"/>
+            <a:off x="987552" y="5001768"/>
+            <a:ext cx="10643616" cy="832103"/>
           </a:xfrm>
           <a:prstGeom prst="rect">
             <a:avLst/>
@@ -4592,14 +4499,11 @@
               </a:defRPr>
             </a:pPr>
             <a:r>
-              <a:t>Repository progress</a:t>
+              <a:t>Observed result</a:t>
             </a:r>
           </a:p>
           <a:p>
             <a:pPr>
-              <a:spcAft>
-                <a:spcPts val="400"/>
-              </a:spcAft>
               <a:defRPr sz="1400">
                 <a:solidFill>
                   <a:srgbClr val="3D4858"/>
@@ -4608,55 +4512,7 @@
               </a:defRPr>
             </a:pPr>
             <a:r>
-              <a:t>The latest branch already contains the prototype improvements and the presentation files.</a:t>
-            </a:r>
-          </a:p>
-          <a:p>
-            <a:pPr>
-              <a:spcAft>
-                <a:spcPts val="400"/>
-              </a:spcAft>
-              <a:defRPr sz="1400">
-                <a:solidFill>
-                  <a:srgbClr val="3D4858"/>
-                </a:solidFill>
-                <a:latin typeface="Aptos"/>
-              </a:defRPr>
-            </a:pPr>
-            <a:r>
-              <a:t>The commit history shows that the work was recorded step by step instead of only being kept locally.</a:t>
-            </a:r>
-          </a:p>
-          <a:p>
-            <a:pPr>
-              <a:spcAft>
-                <a:spcPts val="400"/>
-              </a:spcAft>
-              <a:defRPr sz="1400">
-                <a:solidFill>
-                  <a:srgbClr val="3D4858"/>
-                </a:solidFill>
-                <a:latin typeface="Aptos"/>
-              </a:defRPr>
-            </a:pPr>
-            <a:r>
-              <a:t>This is useful for collaboration because team members can review the exact changes made to the project.</a:t>
-            </a:r>
-          </a:p>
-          <a:p>
-            <a:pPr>
-              <a:spcAft>
-                <a:spcPts val="400"/>
-              </a:spcAft>
-              <a:defRPr sz="1400">
-                <a:solidFill>
-                  <a:srgbClr val="3D4858"/>
-                </a:solidFill>
-                <a:latin typeface="Aptos"/>
-              </a:defRPr>
-            </a:pPr>
-            <a:r>
-              <a:t>The branch can now be used as a clean checkpoint for the next round of development.</a:t>
+              <a:t>On the left, the publishers are actively sending sensor updates and vehicle entry requests. On the right, the statistics service is continuously recalculating free spaces, and the gate controller is reacting to incoming requests by opening the gate when spaces are available. This means the project already supports a full message loop rather than isolated scripts.</a:t>
             </a:r>
           </a:p>
         </p:txBody>
@@ -4759,7 +4615,290 @@
                 </a:solidFill>
                 <a:latin typeface="Aptos"/>
               </a:rPr>
-              <a:t>5. Current Status and Next Step</a:t>
+              <a:t>5. GitHub Progress and Commit Record</a:t>
+            </a:r>
+          </a:p>
+          <a:p>
+            <a:r>
+              <a:rPr sz="1300">
+                <a:solidFill>
+                  <a:srgbClr val="3D4858"/>
+                </a:solidFill>
+                <a:latin typeface="Aptos"/>
+              </a:rPr>
+              <a:t>The repository history now reflects the recent implementation and presentation work.</a:t>
+            </a:r>
+          </a:p>
+        </p:txBody>
+      </p:sp>
+      <p:pic>
+        <p:nvPicPr>
+          <p:cNvPr id="4" name="Picture 3" descr="github_commits_framed.png"/>
+          <p:cNvPicPr>
+            <a:picLocks noChangeAspect="1"/>
+          </p:cNvPicPr>
+          <p:nvPr/>
+        </p:nvPicPr>
+        <p:blipFill>
+          <a:blip r:embed="rId2"/>
+          <a:stretch>
+            <a:fillRect/>
+          </a:stretch>
+        </p:blipFill>
+        <p:spPr>
+          <a:xfrm>
+            <a:off x="658368" y="1417320"/>
+            <a:ext cx="7589520" cy="4800600"/>
+          </a:xfrm>
+          <a:prstGeom prst="rect">
+            <a:avLst/>
+          </a:prstGeom>
+        </p:spPr>
+      </p:pic>
+      <p:sp>
+        <p:nvSpPr>
+          <p:cNvPr id="5" name="Rounded Rectangle 4"/>
+          <p:cNvSpPr/>
+          <p:nvPr/>
+        </p:nvSpPr>
+        <p:spPr>
+          <a:xfrm>
+            <a:off x="8458200" y="1600200"/>
+            <a:ext cx="3063240" cy="4206240"/>
+          </a:xfrm>
+          <a:prstGeom prst="roundRect">
+            <a:avLst/>
+          </a:prstGeom>
+          <a:solidFill>
+            <a:srgbClr val="FFFFFF"/>
+          </a:solidFill>
+          <a:ln>
+            <a:solidFill>
+              <a:srgbClr val="E4ECF7"/>
+            </a:solidFill>
+          </a:ln>
+        </p:spPr>
+        <p:style>
+          <a:lnRef idx="1">
+            <a:schemeClr val="accent1"/>
+          </a:lnRef>
+          <a:fillRef idx="3">
+            <a:schemeClr val="accent1"/>
+          </a:fillRef>
+          <a:effectRef idx="2">
+            <a:schemeClr val="accent1"/>
+          </a:effectRef>
+          <a:fontRef idx="minor">
+            <a:schemeClr val="lt1"/>
+          </a:fontRef>
+        </p:style>
+        <p:txBody>
+          <a:bodyPr rtlCol="0" anchor="ctr"/>
+          <a:lstStyle/>
+          <a:p>
+            <a:pPr algn="ctr"/>
+          </a:p>
+        </p:txBody>
+      </p:sp>
+      <p:sp>
+        <p:nvSpPr>
+          <p:cNvPr id="6" name="TextBox 5"/>
+          <p:cNvSpPr txBox="1"/>
+          <p:nvPr/>
+        </p:nvSpPr>
+        <p:spPr>
+          <a:xfrm>
+            <a:off x="8622792" y="1709928"/>
+            <a:ext cx="2734056" cy="3986783"/>
+          </a:xfrm>
+          <a:prstGeom prst="rect">
+            <a:avLst/>
+          </a:prstGeom>
+          <a:noFill/>
+        </p:spPr>
+        <p:txBody>
+          <a:bodyPr wrap="none">
+            <a:spAutoFit/>
+          </a:bodyPr>
+          <a:lstStyle/>
+          <a:p>
+            <a:pPr>
+              <a:defRPr sz="1800" b="1">
+                <a:solidFill>
+                  <a:srgbClr val="182C4C"/>
+                </a:solidFill>
+                <a:latin typeface="Aptos"/>
+              </a:defRPr>
+            </a:pPr>
+            <a:r>
+              <a:t>Repository progress</a:t>
+            </a:r>
+          </a:p>
+          <a:p>
+            <a:pPr>
+              <a:spcAft>
+                <a:spcPts val="400"/>
+              </a:spcAft>
+              <a:defRPr sz="1400">
+                <a:solidFill>
+                  <a:srgbClr val="3D4858"/>
+                </a:solidFill>
+                <a:latin typeface="Aptos"/>
+              </a:defRPr>
+            </a:pPr>
+            <a:r>
+              <a:t>The latest branch already contains the prototype improvements and the presentation files.</a:t>
+            </a:r>
+          </a:p>
+          <a:p>
+            <a:pPr>
+              <a:spcAft>
+                <a:spcPts val="400"/>
+              </a:spcAft>
+              <a:defRPr sz="1400">
+                <a:solidFill>
+                  <a:srgbClr val="3D4858"/>
+                </a:solidFill>
+                <a:latin typeface="Aptos"/>
+              </a:defRPr>
+            </a:pPr>
+            <a:r>
+              <a:t>The commit history shows that the work was recorded step by step instead of only being kept locally.</a:t>
+            </a:r>
+          </a:p>
+          <a:p>
+            <a:pPr>
+              <a:spcAft>
+                <a:spcPts val="400"/>
+              </a:spcAft>
+              <a:defRPr sz="1400">
+                <a:solidFill>
+                  <a:srgbClr val="3D4858"/>
+                </a:solidFill>
+                <a:latin typeface="Aptos"/>
+              </a:defRPr>
+            </a:pPr>
+            <a:r>
+              <a:t>This is useful for collaboration because team members can review the exact changes made to the project.</a:t>
+            </a:r>
+          </a:p>
+          <a:p>
+            <a:pPr>
+              <a:spcAft>
+                <a:spcPts val="400"/>
+              </a:spcAft>
+              <a:defRPr sz="1400">
+                <a:solidFill>
+                  <a:srgbClr val="3D4858"/>
+                </a:solidFill>
+                <a:latin typeface="Aptos"/>
+              </a:defRPr>
+            </a:pPr>
+            <a:r>
+              <a:t>The branch can now be used as a clean checkpoint for the next round of development.</a:t>
+            </a:r>
+          </a:p>
+        </p:txBody>
+      </p:sp>
+    </p:spTree>
+  </p:cSld>
+  <p:clrMapOvr>
+    <a:masterClrMapping/>
+  </p:clrMapOvr>
+</p:sld>
+</file>
+
+<file path=ppt/slides/slide7.xml><?xml version="1.0" encoding="utf-8"?>
+<p:sld xmlns:a="http://schemas.openxmlformats.org/drawingml/2006/main" xmlns:p="http://schemas.openxmlformats.org/presentationml/2006/main" xmlns:r="http://schemas.openxmlformats.org/officeDocument/2006/relationships">
+  <p:cSld>
+    <p:bg>
+      <p:bgPr>
+        <a:solidFill>
+          <a:srgbClr val="F6F8FC"/>
+        </a:solidFill>
+        <a:effectLst/>
+      </p:bgPr>
+    </p:bg>
+    <p:spTree>
+      <p:nvGrpSpPr>
+        <p:cNvPr id="1" name=""/>
+        <p:cNvGrpSpPr/>
+        <p:nvPr/>
+      </p:nvGrpSpPr>
+      <p:grpSpPr/>
+      <p:sp>
+        <p:nvSpPr>
+          <p:cNvPr id="2" name="Rectangle 1"/>
+          <p:cNvSpPr/>
+          <p:nvPr/>
+        </p:nvSpPr>
+        <p:spPr>
+          <a:xfrm>
+            <a:off x="0" y="0"/>
+            <a:ext cx="12191695" cy="384048"/>
+          </a:xfrm>
+          <a:prstGeom prst="rect">
+            <a:avLst/>
+          </a:prstGeom>
+          <a:solidFill>
+            <a:srgbClr val="182C4C"/>
+          </a:solidFill>
+          <a:ln>
+            <a:noFill/>
+          </a:ln>
+        </p:spPr>
+        <p:style>
+          <a:lnRef idx="1">
+            <a:schemeClr val="accent1"/>
+          </a:lnRef>
+          <a:fillRef idx="3">
+            <a:schemeClr val="accent1"/>
+          </a:fillRef>
+          <a:effectRef idx="2">
+            <a:schemeClr val="accent1"/>
+          </a:effectRef>
+          <a:fontRef idx="minor">
+            <a:schemeClr val="lt1"/>
+          </a:fontRef>
+        </p:style>
+        <p:txBody>
+          <a:bodyPr rtlCol="0" anchor="ctr"/>
+          <a:lstStyle/>
+          <a:p>
+            <a:pPr algn="ctr"/>
+          </a:p>
+        </p:txBody>
+      </p:sp>
+      <p:sp>
+        <p:nvSpPr>
+          <p:cNvPr id="3" name="TextBox 2"/>
+          <p:cNvSpPr txBox="1"/>
+          <p:nvPr/>
+        </p:nvSpPr>
+        <p:spPr>
+          <a:xfrm>
+            <a:off x="640080" y="640080"/>
+            <a:ext cx="10972800" cy="822960"/>
+          </a:xfrm>
+          <a:prstGeom prst="rect">
+            <a:avLst/>
+          </a:prstGeom>
+          <a:noFill/>
+        </p:spPr>
+        <p:txBody>
+          <a:bodyPr wrap="none">
+            <a:spAutoFit/>
+          </a:bodyPr>
+          <a:lstStyle/>
+          <a:p>
+            <a:r>
+              <a:rPr sz="2500" b="1">
+                <a:solidFill>
+                  <a:srgbClr val="182C4C"/>
+                </a:solidFill>
+                <a:latin typeface="Aptos"/>
+              </a:rPr>
+              <a:t>6. Current Status and Next Step</a:t>
             </a:r>
           </a:p>
           <a:p>

</xml_diff>